<commit_message>
Chapter 5 and App v1  completed
</commit_message>
<xml_diff>
--- a/docs/narrative/visual_overview.pptx
+++ b/docs/narrative/visual_overview.pptx
@@ -244,7 +244,7 @@
           <a:p>
             <a:fld id="{EE9F2C0D-35DE-C142-87D7-63D989E280B6}" type="datetimeFigureOut">
               <a:rPr lang="en-US" smtClean="0"/>
-              <a:t>12/30/25</a:t>
+              <a:t>12/31/25</a:t>
             </a:fld>
             <a:endParaRPr lang="en-US"/>
           </a:p>
@@ -414,7 +414,7 @@
           <a:p>
             <a:fld id="{EE9F2C0D-35DE-C142-87D7-63D989E280B6}" type="datetimeFigureOut">
               <a:rPr lang="en-US" smtClean="0"/>
-              <a:t>12/30/25</a:t>
+              <a:t>12/31/25</a:t>
             </a:fld>
             <a:endParaRPr lang="en-US"/>
           </a:p>
@@ -594,7 +594,7 @@
           <a:p>
             <a:fld id="{EE9F2C0D-35DE-C142-87D7-63D989E280B6}" type="datetimeFigureOut">
               <a:rPr lang="en-US" smtClean="0"/>
-              <a:t>12/30/25</a:t>
+              <a:t>12/31/25</a:t>
             </a:fld>
             <a:endParaRPr lang="en-US"/>
           </a:p>
@@ -764,7 +764,7 @@
           <a:p>
             <a:fld id="{EE9F2C0D-35DE-C142-87D7-63D989E280B6}" type="datetimeFigureOut">
               <a:rPr lang="en-US" smtClean="0"/>
-              <a:t>12/30/25</a:t>
+              <a:t>12/31/25</a:t>
             </a:fld>
             <a:endParaRPr lang="en-US"/>
           </a:p>
@@ -1010,7 +1010,7 @@
           <a:p>
             <a:fld id="{EE9F2C0D-35DE-C142-87D7-63D989E280B6}" type="datetimeFigureOut">
               <a:rPr lang="en-US" smtClean="0"/>
-              <a:t>12/30/25</a:t>
+              <a:t>12/31/25</a:t>
             </a:fld>
             <a:endParaRPr lang="en-US"/>
           </a:p>
@@ -1242,7 +1242,7 @@
           <a:p>
             <a:fld id="{EE9F2C0D-35DE-C142-87D7-63D989E280B6}" type="datetimeFigureOut">
               <a:rPr lang="en-US" smtClean="0"/>
-              <a:t>12/30/25</a:t>
+              <a:t>12/31/25</a:t>
             </a:fld>
             <a:endParaRPr lang="en-US"/>
           </a:p>
@@ -1609,7 +1609,7 @@
           <a:p>
             <a:fld id="{EE9F2C0D-35DE-C142-87D7-63D989E280B6}" type="datetimeFigureOut">
               <a:rPr lang="en-US" smtClean="0"/>
-              <a:t>12/30/25</a:t>
+              <a:t>12/31/25</a:t>
             </a:fld>
             <a:endParaRPr lang="en-US"/>
           </a:p>
@@ -1727,7 +1727,7 @@
           <a:p>
             <a:fld id="{EE9F2C0D-35DE-C142-87D7-63D989E280B6}" type="datetimeFigureOut">
               <a:rPr lang="en-US" smtClean="0"/>
-              <a:t>12/30/25</a:t>
+              <a:t>12/31/25</a:t>
             </a:fld>
             <a:endParaRPr lang="en-US"/>
           </a:p>
@@ -1822,7 +1822,7 @@
           <a:p>
             <a:fld id="{EE9F2C0D-35DE-C142-87D7-63D989E280B6}" type="datetimeFigureOut">
               <a:rPr lang="en-US" smtClean="0"/>
-              <a:t>12/30/25</a:t>
+              <a:t>12/31/25</a:t>
             </a:fld>
             <a:endParaRPr lang="en-US"/>
           </a:p>
@@ -2099,7 +2099,7 @@
           <a:p>
             <a:fld id="{EE9F2C0D-35DE-C142-87D7-63D989E280B6}" type="datetimeFigureOut">
               <a:rPr lang="en-US" smtClean="0"/>
-              <a:t>12/30/25</a:t>
+              <a:t>12/31/25</a:t>
             </a:fld>
             <a:endParaRPr lang="en-US"/>
           </a:p>
@@ -2356,7 +2356,7 @@
           <a:p>
             <a:fld id="{EE9F2C0D-35DE-C142-87D7-63D989E280B6}" type="datetimeFigureOut">
               <a:rPr lang="en-US" smtClean="0"/>
-              <a:t>12/30/25</a:t>
+              <a:t>12/31/25</a:t>
             </a:fld>
             <a:endParaRPr lang="en-US"/>
           </a:p>
@@ -2569,7 +2569,7 @@
           <a:p>
             <a:fld id="{EE9F2C0D-35DE-C142-87D7-63D989E280B6}" type="datetimeFigureOut">
               <a:rPr lang="en-US" smtClean="0"/>
-              <a:t>12/30/25</a:t>
+              <a:t>12/31/25</a:t>
             </a:fld>
             <a:endParaRPr lang="en-US"/>
           </a:p>
@@ -4405,7 +4405,7 @@
         </p:nvSpPr>
         <p:spPr>
           <a:xfrm>
-            <a:off x="5999292" y="8125864"/>
+            <a:off x="5999292" y="7957052"/>
             <a:ext cx="1180151" cy="519830"/>
           </a:xfrm>
           <a:prstGeom prst="roundRect">
@@ -4457,7 +4457,7 @@
         </p:nvSpPr>
         <p:spPr>
           <a:xfrm>
-            <a:off x="7356900" y="8125864"/>
+            <a:off x="7356900" y="7957052"/>
             <a:ext cx="1180151" cy="630734"/>
           </a:xfrm>
           <a:prstGeom prst="roundRect">
@@ -5647,7 +5647,7 @@
         </p:nvSpPr>
         <p:spPr>
           <a:xfrm>
-            <a:off x="4569646" y="8006670"/>
+            <a:off x="4569646" y="7837858"/>
             <a:ext cx="1180151" cy="519830"/>
           </a:xfrm>
           <a:prstGeom prst="roundRect">
@@ -6102,8 +6102,8 @@
         </p:nvCxnSpPr>
         <p:spPr>
           <a:xfrm rot="5400000">
-            <a:off x="5077965" y="7640858"/>
-            <a:ext cx="447570" cy="284055"/>
+            <a:off x="5162371" y="7556452"/>
+            <a:ext cx="278758" cy="284055"/>
           </a:xfrm>
           <a:prstGeom prst="curvedConnector3">
             <a:avLst>
@@ -6147,8 +6147,8 @@
         </p:nvCxnSpPr>
         <p:spPr>
           <a:xfrm rot="16200000" flipH="1">
-            <a:off x="5126860" y="8559361"/>
-            <a:ext cx="361413" cy="295689"/>
+            <a:off x="5042454" y="8474955"/>
+            <a:ext cx="530225" cy="295689"/>
           </a:xfrm>
           <a:prstGeom prst="curvedConnector3">
             <a:avLst>
@@ -6191,7 +6191,7 @@
         </p:nvCxnSpPr>
         <p:spPr>
           <a:xfrm rot="16200000" flipH="1">
-            <a:off x="5909684" y="7446180"/>
+            <a:off x="5909684" y="7277368"/>
             <a:ext cx="689870" cy="669498"/>
           </a:xfrm>
           <a:prstGeom prst="curvedConnector3">
@@ -6236,8 +6236,8 @@
         </p:nvCxnSpPr>
         <p:spPr>
           <a:xfrm rot="16200000" flipH="1">
-            <a:off x="7360014" y="7538902"/>
-            <a:ext cx="566764" cy="607159"/>
+            <a:off x="7444420" y="7454496"/>
+            <a:ext cx="397952" cy="607159"/>
           </a:xfrm>
           <a:prstGeom prst="curvedConnector3">
             <a:avLst>
@@ -6281,8 +6281,8 @@
         </p:nvCxnSpPr>
         <p:spPr>
           <a:xfrm rot="5400000">
-            <a:off x="6681211" y="7467258"/>
-            <a:ext cx="566764" cy="750449"/>
+            <a:off x="6765617" y="7382852"/>
+            <a:ext cx="397952" cy="750449"/>
           </a:xfrm>
           <a:prstGeom prst="curvedConnector3">
             <a:avLst>
@@ -8828,7 +8828,7 @@
         </p:nvSpPr>
         <p:spPr>
           <a:xfrm>
-            <a:off x="2590107" y="9195171"/>
+            <a:off x="2437253" y="9296236"/>
             <a:ext cx="1323119" cy="400110"/>
           </a:xfrm>
           <a:prstGeom prst="rect">
@@ -8920,7 +8920,7 @@
         </p:nvSpPr>
         <p:spPr>
           <a:xfrm>
-            <a:off x="6999730" y="9222999"/>
+            <a:off x="6927094" y="9323291"/>
             <a:ext cx="1323119" cy="400110"/>
           </a:xfrm>
           <a:prstGeom prst="rect">
@@ -8959,7 +8959,7 @@
         </p:nvSpPr>
         <p:spPr>
           <a:xfrm>
-            <a:off x="11558815" y="9228335"/>
+            <a:off x="11353250" y="9309411"/>
             <a:ext cx="1323119" cy="400110"/>
           </a:xfrm>
           <a:prstGeom prst="rect">
@@ -9398,6 +9398,241 @@
           <a:p>
             <a:pPr algn="ctr"/>
             <a:endParaRPr lang="en-US"/>
+          </a:p>
+        </p:txBody>
+      </p:sp>
+      <p:sp>
+        <p:nvSpPr>
+          <p:cNvPr id="5" name="TextBox 4">
+            <a:extLst>
+              <a:ext uri="{FF2B5EF4-FFF2-40B4-BE49-F238E27FC236}">
+                <a16:creationId xmlns:a16="http://schemas.microsoft.com/office/drawing/2014/main" id="{58A81FCE-159F-FDC5-790C-D8746A29C82E}"/>
+              </a:ext>
+            </a:extLst>
+          </p:cNvPr>
+          <p:cNvSpPr txBox="1"/>
+          <p:nvPr/>
+        </p:nvSpPr>
+        <p:spPr>
+          <a:xfrm>
+            <a:off x="14834608" y="8245584"/>
+            <a:ext cx="1324722" cy="400110"/>
+          </a:xfrm>
+          <a:prstGeom prst="rect">
+            <a:avLst/>
+          </a:prstGeom>
+          <a:solidFill>
+            <a:schemeClr val="bg2">
+              <a:lumMod val="90000"/>
+            </a:schemeClr>
+          </a:solidFill>
+        </p:spPr>
+        <p:txBody>
+          <a:bodyPr wrap="none" rtlCol="0">
+            <a:spAutoFit/>
+          </a:bodyPr>
+          <a:lstStyle>
+            <a:defPPr>
+              <a:defRPr lang="en-US"/>
+            </a:defPPr>
+            <a:lvl1pPr>
+              <a:defRPr sz="2000" b="1" i="1"/>
+            </a:lvl1pPr>
+          </a:lstStyle>
+          <a:p>
+            <a:r>
+              <a:rPr lang="en-US" dirty="0"/>
+              <a:t>Chapter 5</a:t>
+            </a:r>
+          </a:p>
+        </p:txBody>
+      </p:sp>
+      <p:cxnSp>
+        <p:nvCxnSpPr>
+          <p:cNvPr id="6" name="Curved Connector 5">
+            <a:extLst>
+              <a:ext uri="{FF2B5EF4-FFF2-40B4-BE49-F238E27FC236}">
+                <a16:creationId xmlns:a16="http://schemas.microsoft.com/office/drawing/2014/main" id="{5973B622-0998-046C-77E0-3303001AAEE3}"/>
+              </a:ext>
+            </a:extLst>
+          </p:cNvPr>
+          <p:cNvCxnSpPr>
+            <a:cxnSpLocks/>
+            <a:stCxn id="29" idx="3"/>
+            <a:endCxn id="5" idx="1"/>
+          </p:cNvCxnSpPr>
+          <p:nvPr/>
+        </p:nvCxnSpPr>
+        <p:spPr>
+          <a:xfrm>
+            <a:off x="6066021" y="5157015"/>
+            <a:ext cx="8768587" cy="3288624"/>
+          </a:xfrm>
+          <a:prstGeom prst="curvedConnector3">
+            <a:avLst>
+              <a:gd name="adj1" fmla="val 50000"/>
+            </a:avLst>
+          </a:prstGeom>
+          <a:ln>
+            <a:tailEnd type="triangle"/>
+          </a:ln>
+        </p:spPr>
+        <p:style>
+          <a:lnRef idx="2">
+            <a:schemeClr val="accent1"/>
+          </a:lnRef>
+          <a:fillRef idx="0">
+            <a:schemeClr val="accent1"/>
+          </a:fillRef>
+          <a:effectRef idx="1">
+            <a:schemeClr val="accent1"/>
+          </a:effectRef>
+          <a:fontRef idx="minor">
+            <a:schemeClr val="tx1"/>
+          </a:fontRef>
+        </p:style>
+      </p:cxnSp>
+      <p:cxnSp>
+        <p:nvCxnSpPr>
+          <p:cNvPr id="10" name="Curved Connector 9">
+            <a:extLst>
+              <a:ext uri="{FF2B5EF4-FFF2-40B4-BE49-F238E27FC236}">
+                <a16:creationId xmlns:a16="http://schemas.microsoft.com/office/drawing/2014/main" id="{986D04EA-98A9-6A49-23BD-D5097414E727}"/>
+              </a:ext>
+            </a:extLst>
+          </p:cNvPr>
+          <p:cNvCxnSpPr>
+            <a:cxnSpLocks/>
+            <a:stCxn id="4" idx="2"/>
+            <a:endCxn id="5" idx="0"/>
+          </p:cNvCxnSpPr>
+          <p:nvPr/>
+        </p:nvCxnSpPr>
+        <p:spPr>
+          <a:xfrm rot="5400000">
+            <a:off x="14680475" y="7316533"/>
+            <a:ext cx="1745546" cy="112557"/>
+          </a:xfrm>
+          <a:prstGeom prst="curvedConnector3">
+            <a:avLst>
+              <a:gd name="adj1" fmla="val 50000"/>
+            </a:avLst>
+          </a:prstGeom>
+          <a:ln>
+            <a:tailEnd type="triangle"/>
+          </a:ln>
+        </p:spPr>
+        <p:style>
+          <a:lnRef idx="2">
+            <a:schemeClr val="accent1"/>
+          </a:lnRef>
+          <a:fillRef idx="0">
+            <a:schemeClr val="accent1"/>
+          </a:fillRef>
+          <a:effectRef idx="1">
+            <a:schemeClr val="accent1"/>
+          </a:effectRef>
+          <a:fontRef idx="minor">
+            <a:schemeClr val="tx1"/>
+          </a:fontRef>
+        </p:style>
+      </p:cxnSp>
+      <p:cxnSp>
+        <p:nvCxnSpPr>
+          <p:cNvPr id="50" name="Curved Connector 49">
+            <a:extLst>
+              <a:ext uri="{FF2B5EF4-FFF2-40B4-BE49-F238E27FC236}">
+                <a16:creationId xmlns:a16="http://schemas.microsoft.com/office/drawing/2014/main" id="{915ECB82-53E8-3D8E-5DB5-BA4805EAEDA7}"/>
+              </a:ext>
+            </a:extLst>
+          </p:cNvPr>
+          <p:cNvCxnSpPr>
+            <a:cxnSpLocks/>
+            <a:stCxn id="36" idx="2"/>
+            <a:endCxn id="5" idx="2"/>
+          </p:cNvCxnSpPr>
+          <p:nvPr/>
+        </p:nvCxnSpPr>
+        <p:spPr>
+          <a:xfrm rot="16200000" flipH="1">
+            <a:off x="11693018" y="4841743"/>
+            <a:ext cx="57908" cy="7549993"/>
+          </a:xfrm>
+          <a:prstGeom prst="curvedConnector3">
+            <a:avLst>
+              <a:gd name="adj1" fmla="val 494764"/>
+            </a:avLst>
+          </a:prstGeom>
+          <a:ln>
+            <a:tailEnd type="triangle"/>
+          </a:ln>
+        </p:spPr>
+        <p:style>
+          <a:lnRef idx="2">
+            <a:schemeClr val="accent1"/>
+          </a:lnRef>
+          <a:fillRef idx="0">
+            <a:schemeClr val="accent1"/>
+          </a:fillRef>
+          <a:effectRef idx="1">
+            <a:schemeClr val="accent1"/>
+          </a:effectRef>
+          <a:fontRef idx="minor">
+            <a:schemeClr val="tx1"/>
+          </a:fontRef>
+        </p:style>
+      </p:cxnSp>
+      <p:sp>
+        <p:nvSpPr>
+          <p:cNvPr id="55" name="Rounded Rectangle 54">
+            <a:extLst>
+              <a:ext uri="{FF2B5EF4-FFF2-40B4-BE49-F238E27FC236}">
+                <a16:creationId xmlns:a16="http://schemas.microsoft.com/office/drawing/2014/main" id="{A7D52A1F-A6EE-19F1-49CE-6E97CF8336EA}"/>
+              </a:ext>
+            </a:extLst>
+          </p:cNvPr>
+          <p:cNvSpPr/>
+          <p:nvPr/>
+        </p:nvSpPr>
+        <p:spPr>
+          <a:xfrm>
+            <a:off x="6513662" y="8766103"/>
+            <a:ext cx="1037572" cy="519830"/>
+          </a:xfrm>
+          <a:prstGeom prst="roundRect">
+            <a:avLst/>
+          </a:prstGeom>
+          <a:solidFill>
+            <a:schemeClr val="accent5">
+              <a:lumMod val="75000"/>
+            </a:schemeClr>
+          </a:solidFill>
+        </p:spPr>
+        <p:style>
+          <a:lnRef idx="2">
+            <a:schemeClr val="accent1">
+              <a:shade val="15000"/>
+            </a:schemeClr>
+          </a:lnRef>
+          <a:fillRef idx="1">
+            <a:schemeClr val="accent1"/>
+          </a:fillRef>
+          <a:effectRef idx="0">
+            <a:schemeClr val="accent1"/>
+          </a:effectRef>
+          <a:fontRef idx="minor">
+            <a:schemeClr val="lt1"/>
+          </a:fontRef>
+        </p:style>
+        <p:txBody>
+          <a:bodyPr rtlCol="0" anchor="ctr"/>
+          <a:lstStyle/>
+          <a:p>
+            <a:pPr algn="ctr"/>
+            <a:r>
+              <a:rPr lang="en-US" sz="1200" dirty="0"/>
+              <a:t>Ch2 Pipeline</a:t>
+            </a:r>
           </a:p>
         </p:txBody>
       </p:sp>

</xml_diff>

<commit_message>
Update workflow and documents
</commit_message>
<xml_diff>
--- a/docs/narrative/visual_overview.pptx
+++ b/docs/narrative/visual_overview.pptx
@@ -2976,6 +2976,57 @@
       </p:grpSpPr>
       <p:sp>
         <p:nvSpPr>
+          <p:cNvPr id="7" name="Rounded Rectangle 6">
+            <a:extLst>
+              <a:ext uri="{FF2B5EF4-FFF2-40B4-BE49-F238E27FC236}">
+                <a16:creationId xmlns:a16="http://schemas.microsoft.com/office/drawing/2014/main" id="{2638A7DC-0F9E-58FF-A6B4-2EFA7381799E}"/>
+              </a:ext>
+            </a:extLst>
+          </p:cNvPr>
+          <p:cNvSpPr/>
+          <p:nvPr/>
+        </p:nvSpPr>
+        <p:spPr>
+          <a:xfrm>
+            <a:off x="13325857" y="6569612"/>
+            <a:ext cx="4220088" cy="3207280"/>
+          </a:xfrm>
+          <a:prstGeom prst="roundRect">
+            <a:avLst/>
+          </a:prstGeom>
+          <a:solidFill>
+            <a:schemeClr val="bg1">
+              <a:lumMod val="85000"/>
+            </a:schemeClr>
+          </a:solidFill>
+        </p:spPr>
+        <p:style>
+          <a:lnRef idx="2">
+            <a:schemeClr val="accent1">
+              <a:shade val="15000"/>
+            </a:schemeClr>
+          </a:lnRef>
+          <a:fillRef idx="1">
+            <a:schemeClr val="accent1"/>
+          </a:fillRef>
+          <a:effectRef idx="0">
+            <a:schemeClr val="accent1"/>
+          </a:effectRef>
+          <a:fontRef idx="minor">
+            <a:schemeClr val="lt1"/>
+          </a:fontRef>
+        </p:style>
+        <p:txBody>
+          <a:bodyPr rtlCol="0" anchor="ctr"/>
+          <a:lstStyle/>
+          <a:p>
+            <a:pPr algn="ctr"/>
+            <a:endParaRPr lang="en-US"/>
+          </a:p>
+        </p:txBody>
+      </p:sp>
+      <p:sp>
+        <p:nvSpPr>
           <p:cNvPr id="479" name="Rounded Rectangle 478">
             <a:extLst>
               <a:ext uri="{FF2B5EF4-FFF2-40B4-BE49-F238E27FC236}">
@@ -2989,17 +3040,20 @@
         <p:spPr>
           <a:xfrm>
             <a:off x="412646" y="0"/>
-            <a:ext cx="7677254" cy="619368"/>
+            <a:ext cx="7391418" cy="619368"/>
           </a:xfrm>
           <a:prstGeom prst="roundRect">
             <a:avLst/>
           </a:prstGeom>
           <a:solidFill>
-            <a:schemeClr val="tx1">
-              <a:lumMod val="65000"/>
-              <a:lumOff val="35000"/>
-            </a:schemeClr>
-          </a:solidFill>
+            <a:schemeClr val="bg1"/>
+          </a:solidFill>
+          <a:ln>
+            <a:solidFill>
+              <a:schemeClr val="tx1"/>
+            </a:solidFill>
+            <a:prstDash val="lgDash"/>
+          </a:ln>
         </p:spPr>
         <p:style>
           <a:lnRef idx="2">
@@ -3022,8 +3076,12 @@
           <a:lstStyle/>
           <a:p>
             <a:r>
-              <a:rPr lang="en-US" dirty="0"/>
-              <a:t>Guidelines</a:t>
+              <a:rPr lang="en-US" sz="2400" b="1" i="1" dirty="0">
+                <a:solidFill>
+                  <a:schemeClr val="tx1"/>
+                </a:solidFill>
+              </a:rPr>
+              <a:t>Legend</a:t>
             </a:r>
           </a:p>
         </p:txBody>
@@ -3042,15 +3100,15 @@
         </p:nvSpPr>
         <p:spPr>
           <a:xfrm>
-            <a:off x="13353993" y="660400"/>
-            <a:ext cx="4285953" cy="6276483"/>
+            <a:off x="13325857" y="182097"/>
+            <a:ext cx="4220087" cy="6276483"/>
           </a:xfrm>
           <a:prstGeom prst="roundRect">
             <a:avLst/>
           </a:prstGeom>
           <a:solidFill>
-            <a:schemeClr val="bg2">
-              <a:lumMod val="90000"/>
+            <a:schemeClr val="bg1">
+              <a:lumMod val="85000"/>
             </a:schemeClr>
           </a:solidFill>
         </p:spPr>
@@ -3093,15 +3151,15 @@
         </p:nvSpPr>
         <p:spPr>
           <a:xfrm>
-            <a:off x="8746115" y="660400"/>
-            <a:ext cx="4540117" cy="9116492"/>
+            <a:off x="8746115" y="182097"/>
+            <a:ext cx="4487685" cy="9594795"/>
           </a:xfrm>
           <a:prstGeom prst="roundRect">
             <a:avLst/>
           </a:prstGeom>
           <a:solidFill>
-            <a:schemeClr val="bg2">
-              <a:lumMod val="90000"/>
+            <a:schemeClr val="bg1">
+              <a:lumMod val="85000"/>
             </a:schemeClr>
           </a:solidFill>
         </p:spPr>
@@ -3151,8 +3209,8 @@
             <a:avLst/>
           </a:prstGeom>
           <a:solidFill>
-            <a:schemeClr val="bg2">
-              <a:lumMod val="90000"/>
+            <a:schemeClr val="bg1">
+              <a:lumMod val="85000"/>
             </a:schemeClr>
           </a:solidFill>
         </p:spPr>
@@ -3202,8 +3260,8 @@
             <a:avLst/>
           </a:prstGeom>
           <a:solidFill>
-            <a:schemeClr val="bg2">
-              <a:lumMod val="90000"/>
+            <a:schemeClr val="bg1">
+              <a:lumMod val="85000"/>
             </a:schemeClr>
           </a:solidFill>
         </p:spPr>
@@ -3253,8 +3311,8 @@
             <a:avLst/>
           </a:prstGeom>
           <a:solidFill>
-            <a:schemeClr val="bg2">
-              <a:lumMod val="90000"/>
+            <a:schemeClr val="bg1">
+              <a:lumMod val="85000"/>
             </a:schemeClr>
           </a:solidFill>
         </p:spPr>
@@ -4527,13 +4585,13 @@
         </p:spPr>
         <p:style>
           <a:lnRef idx="2">
-            <a:schemeClr val="accent1"/>
+            <a:schemeClr val="dk1"/>
           </a:lnRef>
           <a:fillRef idx="0">
-            <a:schemeClr val="accent1"/>
+            <a:schemeClr val="dk1"/>
           </a:fillRef>
           <a:effectRef idx="1">
-            <a:schemeClr val="accent1"/>
+            <a:schemeClr val="dk1"/>
           </a:effectRef>
           <a:fontRef idx="minor">
             <a:schemeClr val="tx1"/>
@@ -4554,7 +4612,7 @@
         </p:nvSpPr>
         <p:spPr>
           <a:xfrm>
-            <a:off x="9412710" y="828809"/>
+            <a:off x="9539322" y="392709"/>
             <a:ext cx="1037572" cy="519830"/>
           </a:xfrm>
           <a:prstGeom prst="roundRect">
@@ -4606,7 +4664,7 @@
         </p:nvSpPr>
         <p:spPr>
           <a:xfrm>
-            <a:off x="9282753" y="2039130"/>
+            <a:off x="9282753" y="1617097"/>
             <a:ext cx="1037572" cy="519830"/>
           </a:xfrm>
           <a:prstGeom prst="roundRect">
@@ -4660,7 +4718,7 @@
         </p:nvSpPr>
         <p:spPr>
           <a:xfrm>
-            <a:off x="11551746" y="1981560"/>
+            <a:off x="11551746" y="1559527"/>
             <a:ext cx="1037572" cy="519830"/>
           </a:xfrm>
           <a:prstGeom prst="roundRect">
@@ -4714,7 +4772,7 @@
         </p:nvSpPr>
         <p:spPr>
           <a:xfrm>
-            <a:off x="9518913" y="5192644"/>
+            <a:off x="9518913" y="5248916"/>
             <a:ext cx="1401019" cy="519830"/>
           </a:xfrm>
           <a:prstGeom prst="roundRect">
@@ -4766,7 +4824,7 @@
         </p:nvSpPr>
         <p:spPr>
           <a:xfrm>
-            <a:off x="9055350" y="2851545"/>
+            <a:off x="9055350" y="2809341"/>
             <a:ext cx="1037572" cy="519830"/>
           </a:xfrm>
           <a:prstGeom prst="roundRect">
@@ -4820,7 +4878,7 @@
         </p:nvSpPr>
         <p:spPr>
           <a:xfrm>
-            <a:off x="11417339" y="5192644"/>
+            <a:off x="11417339" y="5248916"/>
             <a:ext cx="1037572" cy="519830"/>
           </a:xfrm>
           <a:prstGeom prst="roundRect">
@@ -4888,13 +4946,13 @@
         </p:spPr>
         <p:style>
           <a:lnRef idx="2">
-            <a:schemeClr val="accent1"/>
+            <a:schemeClr val="dk1"/>
           </a:lnRef>
           <a:fillRef idx="0">
-            <a:schemeClr val="accent1"/>
+            <a:schemeClr val="dk1"/>
           </a:fillRef>
           <a:effectRef idx="1">
-            <a:schemeClr val="accent1"/>
+            <a:schemeClr val="dk1"/>
           </a:effectRef>
           <a:fontRef idx="minor">
             <a:schemeClr val="tx1"/>
@@ -4915,7 +4973,7 @@
         </p:nvSpPr>
         <p:spPr>
           <a:xfrm>
-            <a:off x="12121519" y="4057169"/>
+            <a:off x="11966771" y="4155645"/>
             <a:ext cx="1037572" cy="519830"/>
           </a:xfrm>
           <a:prstGeom prst="roundRect">
@@ -4969,7 +5027,7 @@
         </p:nvSpPr>
         <p:spPr>
           <a:xfrm>
-            <a:off x="10703921" y="4048249"/>
+            <a:off x="10549173" y="4146725"/>
             <a:ext cx="1037572" cy="519830"/>
           </a:xfrm>
           <a:prstGeom prst="roundRect">
@@ -5023,7 +5081,7 @@
         </p:nvSpPr>
         <p:spPr>
           <a:xfrm>
-            <a:off x="15010372" y="3347653"/>
+            <a:off x="15010372" y="2869350"/>
             <a:ext cx="1198308" cy="519830"/>
           </a:xfrm>
           <a:prstGeom prst="roundRect">
@@ -5090,13 +5148,13 @@
         </p:spPr>
         <p:style>
           <a:lnRef idx="2">
-            <a:schemeClr val="accent1"/>
+            <a:schemeClr val="dk1"/>
           </a:lnRef>
           <a:fillRef idx="0">
-            <a:schemeClr val="accent1"/>
+            <a:schemeClr val="dk1"/>
           </a:fillRef>
           <a:effectRef idx="1">
-            <a:schemeClr val="accent1"/>
+            <a:schemeClr val="dk1"/>
           </a:effectRef>
           <a:fontRef idx="minor">
             <a:schemeClr val="tx1"/>
@@ -5135,13 +5193,13 @@
         </p:spPr>
         <p:style>
           <a:lnRef idx="2">
-            <a:schemeClr val="accent1"/>
+            <a:schemeClr val="dk1"/>
           </a:lnRef>
           <a:fillRef idx="0">
-            <a:schemeClr val="accent1"/>
+            <a:schemeClr val="dk1"/>
           </a:fillRef>
           <a:effectRef idx="1">
-            <a:schemeClr val="accent1"/>
+            <a:schemeClr val="dk1"/>
           </a:effectRef>
           <a:fontRef idx="minor">
             <a:schemeClr val="tx1"/>
@@ -5284,13 +5342,13 @@
         </p:spPr>
         <p:style>
           <a:lnRef idx="2">
-            <a:schemeClr val="accent1"/>
+            <a:schemeClr val="dk1"/>
           </a:lnRef>
           <a:fillRef idx="0">
-            <a:schemeClr val="accent1"/>
+            <a:schemeClr val="dk1"/>
           </a:fillRef>
           <a:effectRef idx="1">
-            <a:schemeClr val="accent1"/>
+            <a:schemeClr val="dk1"/>
           </a:effectRef>
           <a:fontRef idx="minor">
             <a:schemeClr val="tx1"/>
@@ -5320,13 +5378,13 @@
         </p:spPr>
         <p:style>
           <a:lnRef idx="2">
-            <a:schemeClr val="accent1"/>
+            <a:schemeClr val="dk1"/>
           </a:lnRef>
           <a:fillRef idx="0">
-            <a:schemeClr val="accent1"/>
+            <a:schemeClr val="dk1"/>
           </a:fillRef>
           <a:effectRef idx="1">
-            <a:schemeClr val="accent1"/>
+            <a:schemeClr val="dk1"/>
           </a:effectRef>
           <a:fontRef idx="minor">
             <a:schemeClr val="tx1"/>
@@ -5493,13 +5551,13 @@
         </p:spPr>
         <p:style>
           <a:lnRef idx="2">
-            <a:schemeClr val="accent1"/>
+            <a:schemeClr val="dk1"/>
           </a:lnRef>
           <a:fillRef idx="0">
-            <a:schemeClr val="accent1"/>
+            <a:schemeClr val="dk1"/>
           </a:fillRef>
           <a:effectRef idx="1">
-            <a:schemeClr val="accent1"/>
+            <a:schemeClr val="dk1"/>
           </a:effectRef>
           <a:fontRef idx="minor">
             <a:schemeClr val="tx1"/>
@@ -5535,13 +5593,13 @@
         </p:spPr>
         <p:style>
           <a:lnRef idx="2">
-            <a:schemeClr val="accent1"/>
+            <a:schemeClr val="dk1"/>
           </a:lnRef>
           <a:fillRef idx="0">
-            <a:schemeClr val="accent1"/>
+            <a:schemeClr val="dk1"/>
           </a:fillRef>
           <a:effectRef idx="1">
-            <a:schemeClr val="accent1"/>
+            <a:schemeClr val="dk1"/>
           </a:effectRef>
           <a:fontRef idx="minor">
             <a:schemeClr val="tx1"/>
@@ -5577,13 +5635,13 @@
         </p:spPr>
         <p:style>
           <a:lnRef idx="2">
-            <a:schemeClr val="accent1"/>
+            <a:schemeClr val="dk1"/>
           </a:lnRef>
           <a:fillRef idx="0">
-            <a:schemeClr val="accent1"/>
+            <a:schemeClr val="dk1"/>
           </a:fillRef>
           <a:effectRef idx="1">
-            <a:schemeClr val="accent1"/>
+            <a:schemeClr val="dk1"/>
           </a:effectRef>
           <a:fontRef idx="minor">
             <a:schemeClr val="tx1"/>
@@ -5620,13 +5678,13 @@
         </p:spPr>
         <p:style>
           <a:lnRef idx="2">
-            <a:schemeClr val="accent1"/>
+            <a:schemeClr val="dk1"/>
           </a:lnRef>
           <a:fillRef idx="0">
-            <a:schemeClr val="accent1"/>
+            <a:schemeClr val="dk1"/>
           </a:fillRef>
           <a:effectRef idx="1">
-            <a:schemeClr val="accent1"/>
+            <a:schemeClr val="dk1"/>
           </a:effectRef>
           <a:fontRef idx="minor">
             <a:schemeClr val="tx1"/>
@@ -5717,13 +5775,13 @@
         </p:spPr>
         <p:style>
           <a:lnRef idx="2">
-            <a:schemeClr val="accent1"/>
+            <a:schemeClr val="dk1"/>
           </a:lnRef>
           <a:fillRef idx="0">
-            <a:schemeClr val="accent1"/>
+            <a:schemeClr val="dk1"/>
           </a:fillRef>
           <a:effectRef idx="1">
-            <a:schemeClr val="accent1"/>
+            <a:schemeClr val="dk1"/>
           </a:effectRef>
           <a:fontRef idx="minor">
             <a:schemeClr val="tx1"/>
@@ -5760,13 +5818,13 @@
         </p:spPr>
         <p:style>
           <a:lnRef idx="2">
-            <a:schemeClr val="accent1"/>
+            <a:schemeClr val="dk1"/>
           </a:lnRef>
           <a:fillRef idx="0">
-            <a:schemeClr val="accent1"/>
+            <a:schemeClr val="dk1"/>
           </a:fillRef>
           <a:effectRef idx="1">
-            <a:schemeClr val="accent1"/>
+            <a:schemeClr val="dk1"/>
           </a:effectRef>
           <a:fontRef idx="minor">
             <a:schemeClr val="tx1"/>
@@ -5803,13 +5861,13 @@
         </p:spPr>
         <p:style>
           <a:lnRef idx="2">
-            <a:schemeClr val="accent1"/>
+            <a:schemeClr val="dk1"/>
           </a:lnRef>
           <a:fillRef idx="0">
-            <a:schemeClr val="accent1"/>
+            <a:schemeClr val="dk1"/>
           </a:fillRef>
           <a:effectRef idx="1">
-            <a:schemeClr val="accent1"/>
+            <a:schemeClr val="dk1"/>
           </a:effectRef>
           <a:fontRef idx="minor">
             <a:schemeClr val="tx1"/>
@@ -5846,13 +5904,13 @@
         </p:spPr>
         <p:style>
           <a:lnRef idx="2">
-            <a:schemeClr val="accent1"/>
+            <a:schemeClr val="dk1"/>
           </a:lnRef>
           <a:fillRef idx="0">
-            <a:schemeClr val="accent1"/>
+            <a:schemeClr val="dk1"/>
           </a:fillRef>
           <a:effectRef idx="1">
-            <a:schemeClr val="accent1"/>
+            <a:schemeClr val="dk1"/>
           </a:effectRef>
           <a:fontRef idx="minor">
             <a:schemeClr val="tx1"/>
@@ -5891,13 +5949,13 @@
         </p:spPr>
         <p:style>
           <a:lnRef idx="2">
-            <a:schemeClr val="accent1"/>
+            <a:schemeClr val="dk1"/>
           </a:lnRef>
           <a:fillRef idx="0">
-            <a:schemeClr val="accent1"/>
+            <a:schemeClr val="dk1"/>
           </a:fillRef>
           <a:effectRef idx="1">
-            <a:schemeClr val="accent1"/>
+            <a:schemeClr val="dk1"/>
           </a:effectRef>
           <a:fontRef idx="minor">
             <a:schemeClr val="tx1"/>
@@ -5936,13 +5994,13 @@
         </p:spPr>
         <p:style>
           <a:lnRef idx="2">
-            <a:schemeClr val="accent1"/>
+            <a:schemeClr val="dk1"/>
           </a:lnRef>
           <a:fillRef idx="0">
-            <a:schemeClr val="accent1"/>
+            <a:schemeClr val="dk1"/>
           </a:fillRef>
           <a:effectRef idx="1">
-            <a:schemeClr val="accent1"/>
+            <a:schemeClr val="dk1"/>
           </a:effectRef>
           <a:fontRef idx="minor">
             <a:schemeClr val="tx1"/>
@@ -5972,7 +6030,7 @@
           </a:xfrm>
           <a:prstGeom prst="curvedConnector3">
             <a:avLst>
-              <a:gd name="adj1" fmla="val 37964"/>
+              <a:gd name="adj1" fmla="val 41957"/>
             </a:avLst>
           </a:prstGeom>
           <a:ln>
@@ -5981,13 +6039,13 @@
         </p:spPr>
         <p:style>
           <a:lnRef idx="2">
-            <a:schemeClr val="accent1"/>
+            <a:schemeClr val="dk1"/>
           </a:lnRef>
           <a:fillRef idx="0">
-            <a:schemeClr val="accent1"/>
+            <a:schemeClr val="dk1"/>
           </a:fillRef>
           <a:effectRef idx="1">
-            <a:schemeClr val="accent1"/>
+            <a:schemeClr val="dk1"/>
           </a:effectRef>
           <a:fontRef idx="minor">
             <a:schemeClr val="tx1"/>
@@ -6026,13 +6084,13 @@
         </p:spPr>
         <p:style>
           <a:lnRef idx="2">
-            <a:schemeClr val="accent1"/>
+            <a:schemeClr val="dk1"/>
           </a:lnRef>
           <a:fillRef idx="0">
-            <a:schemeClr val="accent1"/>
+            <a:schemeClr val="dk1"/>
           </a:fillRef>
           <a:effectRef idx="1">
-            <a:schemeClr val="accent1"/>
+            <a:schemeClr val="dk1"/>
           </a:effectRef>
           <a:fontRef idx="minor">
             <a:schemeClr val="tx1"/>
@@ -6071,13 +6129,13 @@
         </p:spPr>
         <p:style>
           <a:lnRef idx="2">
-            <a:schemeClr val="accent1"/>
+            <a:schemeClr val="dk1"/>
           </a:lnRef>
           <a:fillRef idx="0">
-            <a:schemeClr val="accent1"/>
+            <a:schemeClr val="dk1"/>
           </a:fillRef>
           <a:effectRef idx="1">
-            <a:schemeClr val="accent1"/>
+            <a:schemeClr val="dk1"/>
           </a:effectRef>
           <a:fontRef idx="minor">
             <a:schemeClr val="tx1"/>
@@ -6116,13 +6174,13 @@
         </p:spPr>
         <p:style>
           <a:lnRef idx="2">
-            <a:schemeClr val="accent1"/>
+            <a:schemeClr val="dk1"/>
           </a:lnRef>
           <a:fillRef idx="0">
-            <a:schemeClr val="accent1"/>
+            <a:schemeClr val="dk1"/>
           </a:fillRef>
           <a:effectRef idx="1">
-            <a:schemeClr val="accent1"/>
+            <a:schemeClr val="dk1"/>
           </a:effectRef>
           <a:fontRef idx="minor">
             <a:schemeClr val="tx1"/>
@@ -6161,13 +6219,13 @@
         </p:spPr>
         <p:style>
           <a:lnRef idx="2">
-            <a:schemeClr val="accent1"/>
+            <a:schemeClr val="dk1"/>
           </a:lnRef>
           <a:fillRef idx="0">
-            <a:schemeClr val="accent1"/>
+            <a:schemeClr val="dk1"/>
           </a:fillRef>
           <a:effectRef idx="1">
-            <a:schemeClr val="accent1"/>
+            <a:schemeClr val="dk1"/>
           </a:effectRef>
           <a:fontRef idx="minor">
             <a:schemeClr val="tx1"/>
@@ -6185,19 +6243,18 @@
           </p:cNvPr>
           <p:cNvCxnSpPr>
             <a:cxnSpLocks/>
+            <a:stCxn id="33" idx="3"/>
             <a:endCxn id="35" idx="0"/>
           </p:cNvCxnSpPr>
           <p:nvPr/>
         </p:nvCxnSpPr>
         <p:spPr>
-          <a:xfrm rot="16200000" flipH="1">
-            <a:off x="5909684" y="7277368"/>
-            <a:ext cx="689870" cy="669498"/>
-          </a:xfrm>
-          <a:prstGeom prst="curvedConnector3">
-            <a:avLst>
-              <a:gd name="adj1" fmla="val 50000"/>
-            </a:avLst>
+          <a:xfrm>
+            <a:off x="6016743" y="7299185"/>
+            <a:ext cx="572625" cy="657867"/>
+          </a:xfrm>
+          <a:prstGeom prst="curvedConnector2">
+            <a:avLst/>
           </a:prstGeom>
           <a:ln>
             <a:tailEnd type="triangle"/>
@@ -6205,13 +6262,13 @@
         </p:spPr>
         <p:style>
           <a:lnRef idx="2">
-            <a:schemeClr val="accent1"/>
+            <a:schemeClr val="dk1"/>
           </a:lnRef>
           <a:fillRef idx="0">
-            <a:schemeClr val="accent1"/>
+            <a:schemeClr val="dk1"/>
           </a:fillRef>
           <a:effectRef idx="1">
-            <a:schemeClr val="accent1"/>
+            <a:schemeClr val="dk1"/>
           </a:effectRef>
           <a:fontRef idx="minor">
             <a:schemeClr val="tx1"/>
@@ -6250,13 +6307,13 @@
         </p:spPr>
         <p:style>
           <a:lnRef idx="2">
-            <a:schemeClr val="accent1"/>
+            <a:schemeClr val="dk1"/>
           </a:lnRef>
           <a:fillRef idx="0">
-            <a:schemeClr val="accent1"/>
+            <a:schemeClr val="dk1"/>
           </a:fillRef>
           <a:effectRef idx="1">
-            <a:schemeClr val="accent1"/>
+            <a:schemeClr val="dk1"/>
           </a:effectRef>
           <a:fontRef idx="minor">
             <a:schemeClr val="tx1"/>
@@ -6295,13 +6352,13 @@
         </p:spPr>
         <p:style>
           <a:lnRef idx="2">
-            <a:schemeClr val="accent1"/>
+            <a:schemeClr val="dk1"/>
           </a:lnRef>
           <a:fillRef idx="0">
-            <a:schemeClr val="accent1"/>
+            <a:schemeClr val="dk1"/>
           </a:fillRef>
           <a:effectRef idx="1">
-            <a:schemeClr val="accent1"/>
+            <a:schemeClr val="dk1"/>
           </a:effectRef>
           <a:fontRef idx="minor">
             <a:schemeClr val="tx1"/>
@@ -6340,13 +6397,13 @@
         </p:spPr>
         <p:style>
           <a:lnRef idx="2">
-            <a:schemeClr val="accent1"/>
+            <a:schemeClr val="dk1"/>
           </a:lnRef>
           <a:fillRef idx="0">
-            <a:schemeClr val="accent1"/>
+            <a:schemeClr val="dk1"/>
           </a:fillRef>
           <a:effectRef idx="1">
-            <a:schemeClr val="accent1"/>
+            <a:schemeClr val="dk1"/>
           </a:effectRef>
           <a:fontRef idx="minor">
             <a:schemeClr val="tx1"/>
@@ -6385,13 +6442,13 @@
         </p:spPr>
         <p:style>
           <a:lnRef idx="2">
-            <a:schemeClr val="accent1"/>
+            <a:schemeClr val="dk1"/>
           </a:lnRef>
           <a:fillRef idx="0">
-            <a:schemeClr val="accent1"/>
+            <a:schemeClr val="dk1"/>
           </a:fillRef>
           <a:effectRef idx="1">
-            <a:schemeClr val="accent1"/>
+            <a:schemeClr val="dk1"/>
           </a:effectRef>
           <a:fontRef idx="minor">
             <a:schemeClr val="tx1"/>
@@ -6428,13 +6485,13 @@
         </p:spPr>
         <p:style>
           <a:lnRef idx="2">
-            <a:schemeClr val="accent1"/>
+            <a:schemeClr val="dk1"/>
           </a:lnRef>
           <a:fillRef idx="0">
-            <a:schemeClr val="accent1"/>
+            <a:schemeClr val="dk1"/>
           </a:fillRef>
           <a:effectRef idx="1">
-            <a:schemeClr val="accent1"/>
+            <a:schemeClr val="dk1"/>
           </a:effectRef>
           <a:fontRef idx="minor">
             <a:schemeClr val="tx1"/>
@@ -6527,13 +6584,13 @@
         </p:spPr>
         <p:style>
           <a:lnRef idx="2">
-            <a:schemeClr val="accent1"/>
+            <a:schemeClr val="dk1"/>
           </a:lnRef>
           <a:fillRef idx="0">
-            <a:schemeClr val="accent1"/>
+            <a:schemeClr val="dk1"/>
           </a:fillRef>
           <a:effectRef idx="1">
-            <a:schemeClr val="accent1"/>
+            <a:schemeClr val="dk1"/>
           </a:effectRef>
           <a:fontRef idx="minor">
             <a:schemeClr val="tx1"/>
@@ -6572,13 +6629,13 @@
         </p:spPr>
         <p:style>
           <a:lnRef idx="2">
-            <a:schemeClr val="accent1"/>
+            <a:schemeClr val="dk1"/>
           </a:lnRef>
           <a:fillRef idx="0">
-            <a:schemeClr val="accent1"/>
+            <a:schemeClr val="dk1"/>
           </a:fillRef>
           <a:effectRef idx="1">
-            <a:schemeClr val="accent1"/>
+            <a:schemeClr val="dk1"/>
           </a:effectRef>
           <a:fontRef idx="minor">
             <a:schemeClr val="tx1"/>
@@ -6602,9 +6659,9 @@
           <p:nvPr/>
         </p:nvCxnSpPr>
         <p:spPr>
-          <a:xfrm>
-            <a:off x="7087717" y="1088724"/>
-            <a:ext cx="2324993" cy="12700"/>
+          <a:xfrm flipV="1">
+            <a:off x="7087717" y="652624"/>
+            <a:ext cx="2451605" cy="436100"/>
           </a:xfrm>
           <a:prstGeom prst="curvedConnector3">
             <a:avLst>
@@ -6617,13 +6674,13 @@
         </p:spPr>
         <p:style>
           <a:lnRef idx="2">
-            <a:schemeClr val="accent1"/>
+            <a:schemeClr val="dk1"/>
           </a:lnRef>
           <a:fillRef idx="0">
-            <a:schemeClr val="accent1"/>
+            <a:schemeClr val="dk1"/>
           </a:fillRef>
           <a:effectRef idx="1">
-            <a:schemeClr val="accent1"/>
+            <a:schemeClr val="dk1"/>
           </a:effectRef>
           <a:fontRef idx="minor">
             <a:schemeClr val="tx1"/>
@@ -6644,7 +6701,7 @@
         </p:nvSpPr>
         <p:spPr>
           <a:xfrm>
-            <a:off x="11376382" y="828807"/>
+            <a:off x="11502994" y="392707"/>
             <a:ext cx="1037572" cy="519830"/>
           </a:xfrm>
           <a:prstGeom prst="roundRect">
@@ -6696,7 +6753,7 @@
         </p:nvSpPr>
         <p:spPr>
           <a:xfrm>
-            <a:off x="11551746" y="2832556"/>
+            <a:off x="11551746" y="2790352"/>
             <a:ext cx="1037572" cy="519830"/>
           </a:xfrm>
           <a:prstGeom prst="roundRect">
@@ -6753,7 +6810,7 @@
         </p:nvCxnSpPr>
         <p:spPr>
           <a:xfrm flipV="1">
-            <a:off x="10450282" y="1088722"/>
+            <a:off x="10576894" y="652622"/>
             <a:ext cx="926100" cy="2"/>
           </a:xfrm>
           <a:prstGeom prst="curvedConnector3">
@@ -6767,13 +6824,13 @@
         </p:spPr>
         <p:style>
           <a:lnRef idx="2">
-            <a:schemeClr val="accent1"/>
+            <a:schemeClr val="dk1"/>
           </a:lnRef>
           <a:fillRef idx="0">
-            <a:schemeClr val="accent1"/>
+            <a:schemeClr val="dk1"/>
           </a:fillRef>
           <a:effectRef idx="1">
-            <a:schemeClr val="accent1"/>
+            <a:schemeClr val="dk1"/>
           </a:effectRef>
           <a:fontRef idx="minor">
             <a:schemeClr val="tx1"/>
@@ -6798,8 +6855,8 @@
         </p:nvCxnSpPr>
         <p:spPr>
           <a:xfrm rot="16200000" flipH="1">
-            <a:off x="11666389" y="1577416"/>
-            <a:ext cx="632923" cy="175364"/>
+            <a:off x="11722661" y="1211656"/>
+            <a:ext cx="646990" cy="48752"/>
           </a:xfrm>
           <a:prstGeom prst="curvedConnector3">
             <a:avLst>
@@ -6812,13 +6869,13 @@
         </p:spPr>
         <p:style>
           <a:lnRef idx="2">
-            <a:schemeClr val="accent1"/>
+            <a:schemeClr val="dk1"/>
           </a:lnRef>
           <a:fillRef idx="0">
-            <a:schemeClr val="accent1"/>
+            <a:schemeClr val="dk1"/>
           </a:fillRef>
           <a:effectRef idx="1">
-            <a:schemeClr val="accent1"/>
+            <a:schemeClr val="dk1"/>
           </a:effectRef>
           <a:fontRef idx="minor">
             <a:schemeClr val="tx1"/>
@@ -6843,8 +6900,8 @@
         </p:nvCxnSpPr>
         <p:spPr>
           <a:xfrm rot="5400000">
-            <a:off x="11904949" y="2666973"/>
-            <a:ext cx="331166" cy="12700"/>
+            <a:off x="11715035" y="2434854"/>
+            <a:ext cx="710995" cy="12700"/>
           </a:xfrm>
           <a:prstGeom prst="curvedConnector3">
             <a:avLst>
@@ -6857,13 +6914,13 @@
         </p:spPr>
         <p:style>
           <a:lnRef idx="2">
-            <a:schemeClr val="accent1"/>
+            <a:schemeClr val="dk1"/>
           </a:lnRef>
           <a:fillRef idx="0">
-            <a:schemeClr val="accent1"/>
+            <a:schemeClr val="dk1"/>
           </a:fillRef>
           <a:effectRef idx="1">
-            <a:schemeClr val="accent1"/>
+            <a:schemeClr val="dk1"/>
           </a:effectRef>
           <a:fontRef idx="minor">
             <a:schemeClr val="tx1"/>
@@ -6888,8 +6945,8 @@
         </p:nvCxnSpPr>
         <p:spPr>
           <a:xfrm flipV="1">
-            <a:off x="8322849" y="2299045"/>
-            <a:ext cx="959904" cy="2144660"/>
+            <a:off x="8322849" y="1877012"/>
+            <a:ext cx="959904" cy="2566693"/>
           </a:xfrm>
           <a:prstGeom prst="curvedConnector3">
             <a:avLst>
@@ -6902,13 +6959,13 @@
         </p:spPr>
         <p:style>
           <a:lnRef idx="2">
-            <a:schemeClr val="accent1"/>
+            <a:schemeClr val="dk1"/>
           </a:lnRef>
           <a:fillRef idx="0">
-            <a:schemeClr val="accent1"/>
+            <a:schemeClr val="dk1"/>
           </a:fillRef>
           <a:effectRef idx="1">
-            <a:schemeClr val="accent1"/>
+            <a:schemeClr val="dk1"/>
           </a:effectRef>
           <a:fontRef idx="minor">
             <a:schemeClr val="tx1"/>
@@ -6933,8 +6990,8 @@
         </p:nvCxnSpPr>
         <p:spPr>
           <a:xfrm rot="5400000">
-            <a:off x="10503108" y="647069"/>
-            <a:ext cx="690493" cy="2093629"/>
+            <a:off x="10559380" y="154697"/>
+            <a:ext cx="704560" cy="2220241"/>
           </a:xfrm>
           <a:prstGeom prst="curvedConnector3">
             <a:avLst>
@@ -6947,13 +7004,13 @@
         </p:spPr>
         <p:style>
           <a:lnRef idx="2">
-            <a:schemeClr val="accent1"/>
+            <a:schemeClr val="dk1"/>
           </a:lnRef>
           <a:fillRef idx="0">
-            <a:schemeClr val="accent1"/>
+            <a:schemeClr val="dk1"/>
           </a:fillRef>
           <a:effectRef idx="1">
-            <a:schemeClr val="accent1"/>
+            <a:schemeClr val="dk1"/>
           </a:effectRef>
           <a:fontRef idx="minor">
             <a:schemeClr val="tx1"/>
@@ -6978,8 +7035,8 @@
         </p:nvCxnSpPr>
         <p:spPr>
           <a:xfrm rot="10800000">
-            <a:off x="10320326" y="2299045"/>
-            <a:ext cx="1231421" cy="793426"/>
+            <a:off x="10320326" y="1877013"/>
+            <a:ext cx="1231421" cy="1173255"/>
           </a:xfrm>
           <a:prstGeom prst="curvedConnector3">
             <a:avLst>
@@ -6992,13 +7049,13 @@
         </p:spPr>
         <p:style>
           <a:lnRef idx="2">
-            <a:schemeClr val="accent1"/>
+            <a:schemeClr val="dk1"/>
           </a:lnRef>
           <a:fillRef idx="0">
-            <a:schemeClr val="accent1"/>
+            <a:schemeClr val="dk1"/>
           </a:fillRef>
           <a:effectRef idx="1">
-            <a:schemeClr val="accent1"/>
+            <a:schemeClr val="dk1"/>
           </a:effectRef>
           <a:fontRef idx="minor">
             <a:schemeClr val="tx1"/>
@@ -7019,7 +7076,7 @@
         </p:nvSpPr>
         <p:spPr>
           <a:xfrm>
-            <a:off x="9259867" y="4046834"/>
+            <a:off x="9105119" y="4145310"/>
             <a:ext cx="1037572" cy="519830"/>
           </a:xfrm>
           <a:prstGeom prst="roundRect">
@@ -7077,8 +7134,8 @@
         </p:nvCxnSpPr>
         <p:spPr>
           <a:xfrm flipV="1">
-            <a:off x="8322849" y="3371375"/>
-            <a:ext cx="1251287" cy="1072330"/>
+            <a:off x="8322849" y="3329171"/>
+            <a:ext cx="1251287" cy="1114534"/>
           </a:xfrm>
           <a:prstGeom prst="curvedConnector2">
             <a:avLst/>
@@ -7089,13 +7146,13 @@
         </p:spPr>
         <p:style>
           <a:lnRef idx="2">
-            <a:schemeClr val="accent1"/>
+            <a:schemeClr val="dk1"/>
           </a:lnRef>
           <a:fillRef idx="0">
-            <a:schemeClr val="accent1"/>
+            <a:schemeClr val="dk1"/>
           </a:fillRef>
           <a:effectRef idx="1">
-            <a:schemeClr val="accent1"/>
+            <a:schemeClr val="dk1"/>
           </a:effectRef>
           <a:fontRef idx="minor">
             <a:schemeClr val="tx1"/>
@@ -7120,8 +7177,8 @@
         </p:nvCxnSpPr>
         <p:spPr>
           <a:xfrm rot="16200000" flipH="1">
-            <a:off x="9338665" y="3606845"/>
-            <a:ext cx="675459" cy="204517"/>
+            <a:off x="9190951" y="3712355"/>
+            <a:ext cx="816139" cy="49769"/>
           </a:xfrm>
           <a:prstGeom prst="curvedConnector3">
             <a:avLst>
@@ -7134,13 +7191,13 @@
         </p:spPr>
         <p:style>
           <a:lnRef idx="2">
-            <a:schemeClr val="accent1"/>
+            <a:schemeClr val="dk1"/>
           </a:lnRef>
           <a:fillRef idx="0">
-            <a:schemeClr val="accent1"/>
+            <a:schemeClr val="dk1"/>
           </a:fillRef>
           <a:effectRef idx="1">
-            <a:schemeClr val="accent1"/>
+            <a:schemeClr val="dk1"/>
           </a:effectRef>
           <a:fontRef idx="minor">
             <a:schemeClr val="tx1"/>
@@ -7165,8 +7222,8 @@
         </p:nvCxnSpPr>
         <p:spPr>
           <a:xfrm rot="5400000">
-            <a:off x="10577369" y="2553671"/>
-            <a:ext cx="694448" cy="2291879"/>
+            <a:off x="10429655" y="2504433"/>
+            <a:ext cx="835128" cy="2446627"/>
           </a:xfrm>
           <a:prstGeom prst="curvedConnector3">
             <a:avLst>
@@ -7179,13 +7236,13 @@
         </p:spPr>
         <p:style>
           <a:lnRef idx="2">
-            <a:schemeClr val="accent1"/>
+            <a:schemeClr val="dk1"/>
           </a:lnRef>
           <a:fillRef idx="0">
-            <a:schemeClr val="accent1"/>
+            <a:schemeClr val="dk1"/>
           </a:fillRef>
           <a:effectRef idx="1">
-            <a:schemeClr val="accent1"/>
+            <a:schemeClr val="dk1"/>
           </a:effectRef>
           <a:fontRef idx="minor">
             <a:schemeClr val="tx1"/>
@@ -7210,8 +7267,8 @@
         </p:nvCxnSpPr>
         <p:spPr>
           <a:xfrm rot="5400000">
-            <a:off x="11298689" y="3276405"/>
-            <a:ext cx="695863" cy="847825"/>
+            <a:off x="11150975" y="3227167"/>
+            <a:ext cx="836543" cy="1002573"/>
           </a:xfrm>
           <a:prstGeom prst="curvedConnector3">
             <a:avLst>
@@ -7224,13 +7281,13 @@
         </p:spPr>
         <p:style>
           <a:lnRef idx="2">
-            <a:schemeClr val="accent1"/>
+            <a:schemeClr val="dk1"/>
           </a:lnRef>
           <a:fillRef idx="0">
-            <a:schemeClr val="accent1"/>
+            <a:schemeClr val="dk1"/>
           </a:fillRef>
           <a:effectRef idx="1">
-            <a:schemeClr val="accent1"/>
+            <a:schemeClr val="dk1"/>
           </a:effectRef>
           <a:fontRef idx="minor">
             <a:schemeClr val="tx1"/>
@@ -7255,8 +7312,8 @@
         </p:nvCxnSpPr>
         <p:spPr>
           <a:xfrm rot="16200000" flipH="1">
-            <a:off x="12003027" y="3419890"/>
-            <a:ext cx="704783" cy="569773"/>
+            <a:off x="11855313" y="3525400"/>
+            <a:ext cx="845463" cy="415025"/>
           </a:xfrm>
           <a:prstGeom prst="curvedConnector3">
             <a:avLst>
@@ -7269,13 +7326,13 @@
         </p:spPr>
         <p:style>
           <a:lnRef idx="2">
-            <a:schemeClr val="accent1"/>
+            <a:schemeClr val="dk1"/>
           </a:lnRef>
           <a:fillRef idx="0">
-            <a:schemeClr val="accent1"/>
+            <a:schemeClr val="dk1"/>
           </a:fillRef>
           <a:effectRef idx="1">
-            <a:schemeClr val="accent1"/>
+            <a:schemeClr val="dk1"/>
           </a:effectRef>
           <a:fontRef idx="minor">
             <a:schemeClr val="tx1"/>
@@ -7300,13 +7357,13 @@
         </p:nvCxnSpPr>
         <p:spPr>
           <a:xfrm flipH="1">
-            <a:off x="10219423" y="2299045"/>
-            <a:ext cx="100902" cy="2893599"/>
+            <a:off x="10219423" y="1877012"/>
+            <a:ext cx="100902" cy="3371904"/>
           </a:xfrm>
           <a:prstGeom prst="curvedConnector4">
             <a:avLst>
               <a:gd name="adj1" fmla="val -226556"/>
-              <a:gd name="adj2" fmla="val 78832"/>
+              <a:gd name="adj2" fmla="val 53854"/>
             </a:avLst>
           </a:prstGeom>
           <a:ln>
@@ -7315,13 +7372,13 @@
         </p:spPr>
         <p:style>
           <a:lnRef idx="2">
-            <a:schemeClr val="accent1"/>
+            <a:schemeClr val="dk1"/>
           </a:lnRef>
           <a:fillRef idx="0">
-            <a:schemeClr val="accent1"/>
+            <a:schemeClr val="dk1"/>
           </a:fillRef>
           <a:effectRef idx="1">
-            <a:schemeClr val="accent1"/>
+            <a:schemeClr val="dk1"/>
           </a:effectRef>
           <a:fontRef idx="minor">
             <a:schemeClr val="tx1"/>
@@ -7346,8 +7403,8 @@
         </p:nvCxnSpPr>
         <p:spPr>
           <a:xfrm rot="16200000" flipH="1">
-            <a:off x="9686048" y="4659269"/>
-            <a:ext cx="625980" cy="440770"/>
+            <a:off x="9629776" y="4659269"/>
+            <a:ext cx="583776" cy="595518"/>
           </a:xfrm>
           <a:prstGeom prst="curvedConnector3">
             <a:avLst>
@@ -7360,13 +7417,13 @@
         </p:spPr>
         <p:style>
           <a:lnRef idx="2">
-            <a:schemeClr val="accent1"/>
+            <a:schemeClr val="dk1"/>
           </a:lnRef>
           <a:fillRef idx="0">
-            <a:schemeClr val="accent1"/>
+            <a:schemeClr val="dk1"/>
           </a:fillRef>
           <a:effectRef idx="1">
-            <a:schemeClr val="accent1"/>
+            <a:schemeClr val="dk1"/>
           </a:effectRef>
           <a:fontRef idx="minor">
             <a:schemeClr val="tx1"/>
@@ -7391,8 +7448,8 @@
         </p:nvCxnSpPr>
         <p:spPr>
           <a:xfrm rot="5400000">
-            <a:off x="10408783" y="4378719"/>
-            <a:ext cx="624565" cy="1003284"/>
+            <a:off x="10352511" y="4533467"/>
+            <a:ext cx="582361" cy="848536"/>
           </a:xfrm>
           <a:prstGeom prst="curvedConnector3">
             <a:avLst>
@@ -7405,13 +7462,13 @@
         </p:spPr>
         <p:style>
           <a:lnRef idx="2">
-            <a:schemeClr val="accent1"/>
+            <a:schemeClr val="dk1"/>
           </a:lnRef>
           <a:fillRef idx="0">
-            <a:schemeClr val="accent1"/>
+            <a:schemeClr val="dk1"/>
           </a:fillRef>
           <a:effectRef idx="1">
-            <a:schemeClr val="accent1"/>
+            <a:schemeClr val="dk1"/>
           </a:effectRef>
           <a:fontRef idx="minor">
             <a:schemeClr val="tx1"/>
@@ -7436,8 +7493,8 @@
         </p:nvCxnSpPr>
         <p:spPr>
           <a:xfrm rot="16200000" flipH="1">
-            <a:off x="11267134" y="4523652"/>
-            <a:ext cx="624565" cy="713418"/>
+            <a:off x="11210862" y="4523652"/>
+            <a:ext cx="582361" cy="868166"/>
           </a:xfrm>
           <a:prstGeom prst="curvedConnector3">
             <a:avLst>
@@ -7450,13 +7507,13 @@
         </p:spPr>
         <p:style>
           <a:lnRef idx="2">
-            <a:schemeClr val="accent1"/>
+            <a:schemeClr val="dk1"/>
           </a:lnRef>
           <a:fillRef idx="0">
-            <a:schemeClr val="accent1"/>
+            <a:schemeClr val="dk1"/>
           </a:fillRef>
           <a:effectRef idx="1">
-            <a:schemeClr val="accent1"/>
+            <a:schemeClr val="dk1"/>
           </a:effectRef>
           <a:fontRef idx="minor">
             <a:schemeClr val="tx1"/>
@@ -7481,8 +7538,8 @@
         </p:nvCxnSpPr>
         <p:spPr>
           <a:xfrm rot="5400000">
-            <a:off x="11980393" y="4532731"/>
-            <a:ext cx="615645" cy="704180"/>
+            <a:off x="11924121" y="4687479"/>
+            <a:ext cx="573441" cy="549432"/>
           </a:xfrm>
           <a:prstGeom prst="curvedConnector3">
             <a:avLst>
@@ -7495,13 +7552,13 @@
         </p:spPr>
         <p:style>
           <a:lnRef idx="2">
-            <a:schemeClr val="accent1"/>
+            <a:schemeClr val="dk1"/>
           </a:lnRef>
           <a:fillRef idx="0">
-            <a:schemeClr val="accent1"/>
+            <a:schemeClr val="dk1"/>
           </a:fillRef>
           <a:effectRef idx="1">
-            <a:schemeClr val="accent1"/>
+            <a:schemeClr val="dk1"/>
           </a:effectRef>
           <a:fontRef idx="minor">
             <a:schemeClr val="tx1"/>
@@ -7522,7 +7579,7 @@
         </p:nvSpPr>
         <p:spPr>
           <a:xfrm>
-            <a:off x="10535241" y="7354460"/>
+            <a:off x="10549309" y="7467004"/>
             <a:ext cx="1037572" cy="519830"/>
           </a:xfrm>
           <a:prstGeom prst="roundRect">
@@ -7576,7 +7633,7 @@
         </p:nvSpPr>
         <p:spPr>
           <a:xfrm>
-            <a:off x="10522715" y="8328242"/>
+            <a:off x="10550851" y="8468922"/>
             <a:ext cx="1037572" cy="519830"/>
           </a:xfrm>
           <a:prstGeom prst="roundRect">
@@ -7628,7 +7685,7 @@
         </p:nvSpPr>
         <p:spPr>
           <a:xfrm rot="16200000">
-            <a:off x="10843393" y="4918810"/>
+            <a:off x="10787121" y="4946946"/>
             <a:ext cx="501041" cy="4146113"/>
           </a:xfrm>
           <a:prstGeom prst="leftBrace">
@@ -7637,13 +7694,13 @@
         </p:spPr>
         <p:style>
           <a:lnRef idx="2">
-            <a:schemeClr val="accent1"/>
+            <a:schemeClr val="dk1"/>
           </a:lnRef>
           <a:fillRef idx="0">
-            <a:schemeClr val="accent1"/>
+            <a:schemeClr val="dk1"/>
           </a:fillRef>
           <a:effectRef idx="1">
-            <a:schemeClr val="accent1"/>
+            <a:schemeClr val="dk1"/>
           </a:effectRef>
           <a:fontRef idx="minor">
             <a:schemeClr val="tx1"/>
@@ -7672,7 +7729,7 @@
         </p:nvSpPr>
         <p:spPr>
           <a:xfrm>
-            <a:off x="10502380" y="6190002"/>
+            <a:off x="10502380" y="6288478"/>
             <a:ext cx="1037572" cy="519830"/>
           </a:xfrm>
           <a:prstGeom prst="roundRect">
@@ -7729,9 +7786,9 @@
           <p:nvPr/>
         </p:nvCxnSpPr>
         <p:spPr>
-          <a:xfrm rot="5400000">
-            <a:off x="10820788" y="8095003"/>
-            <a:ext cx="453952" cy="12526"/>
+          <a:xfrm rot="16200000" flipH="1">
+            <a:off x="10827822" y="8227107"/>
+            <a:ext cx="482088" cy="1542"/>
           </a:xfrm>
           <a:prstGeom prst="curvedConnector3">
             <a:avLst>
@@ -7744,13 +7801,13 @@
         </p:spPr>
         <p:style>
           <a:lnRef idx="2">
-            <a:schemeClr val="accent1"/>
+            <a:schemeClr val="dk1"/>
           </a:lnRef>
           <a:fillRef idx="0">
-            <a:schemeClr val="accent1"/>
+            <a:schemeClr val="dk1"/>
           </a:fillRef>
           <a:effectRef idx="1">
-            <a:schemeClr val="accent1"/>
+            <a:schemeClr val="dk1"/>
           </a:effectRef>
           <a:fontRef idx="minor">
             <a:schemeClr val="tx1"/>
@@ -7775,8 +7832,8 @@
         </p:nvCxnSpPr>
         <p:spPr>
           <a:xfrm rot="5400000" flipH="1" flipV="1">
-            <a:off x="11239881" y="5493759"/>
-            <a:ext cx="477528" cy="914959"/>
+            <a:off x="11218779" y="5571133"/>
+            <a:ext cx="519732" cy="914959"/>
           </a:xfrm>
           <a:prstGeom prst="curvedConnector3">
             <a:avLst>
@@ -7789,13 +7846,13 @@
         </p:spPr>
         <p:style>
           <a:lnRef idx="2">
-            <a:schemeClr val="accent1"/>
+            <a:schemeClr val="dk1"/>
           </a:lnRef>
           <a:fillRef idx="0">
-            <a:schemeClr val="accent1"/>
+            <a:schemeClr val="dk1"/>
           </a:fillRef>
           <a:effectRef idx="1">
-            <a:schemeClr val="accent1"/>
+            <a:schemeClr val="dk1"/>
           </a:effectRef>
           <a:fontRef idx="minor">
             <a:schemeClr val="tx1"/>
@@ -7820,8 +7877,8 @@
         </p:nvCxnSpPr>
         <p:spPr>
           <a:xfrm rot="16200000" flipV="1">
-            <a:off x="10381531" y="5550366"/>
-            <a:ext cx="477528" cy="801743"/>
+            <a:off x="10360429" y="5627740"/>
+            <a:ext cx="519732" cy="801743"/>
           </a:xfrm>
           <a:prstGeom prst="curvedConnector3">
             <a:avLst>
@@ -7834,13 +7891,13 @@
         </p:spPr>
         <p:style>
           <a:lnRef idx="2">
-            <a:schemeClr val="accent1"/>
+            <a:schemeClr val="dk1"/>
           </a:lnRef>
           <a:fillRef idx="0">
-            <a:schemeClr val="accent1"/>
+            <a:schemeClr val="dk1"/>
           </a:fillRef>
           <a:effectRef idx="1">
-            <a:schemeClr val="accent1"/>
+            <a:schemeClr val="dk1"/>
           </a:effectRef>
           <a:fontRef idx="minor">
             <a:schemeClr val="tx1"/>
@@ -7861,7 +7918,7 @@
         </p:nvSpPr>
         <p:spPr>
           <a:xfrm>
-            <a:off x="16139991" y="1702717"/>
+            <a:off x="16139991" y="1224414"/>
             <a:ext cx="1037572" cy="519830"/>
           </a:xfrm>
           <a:prstGeom prst="roundRect">
@@ -7913,7 +7970,7 @@
         </p:nvSpPr>
         <p:spPr>
           <a:xfrm>
-            <a:off x="13952827" y="841509"/>
+            <a:off x="13952827" y="363206"/>
             <a:ext cx="1037572" cy="519830"/>
           </a:xfrm>
           <a:prstGeom prst="roundRect">
@@ -7967,7 +8024,7 @@
         </p:nvSpPr>
         <p:spPr>
           <a:xfrm>
-            <a:off x="16127466" y="841509"/>
+            <a:off x="16127466" y="363206"/>
             <a:ext cx="1037572" cy="519830"/>
           </a:xfrm>
           <a:prstGeom prst="roundRect">
@@ -8021,7 +8078,7 @@
         </p:nvSpPr>
         <p:spPr>
           <a:xfrm>
-            <a:off x="13799878" y="1727064"/>
+            <a:off x="13799878" y="1248761"/>
             <a:ext cx="1340972" cy="519830"/>
           </a:xfrm>
           <a:prstGeom prst="roundRect">
@@ -8079,7 +8136,7 @@
         </p:nvCxnSpPr>
         <p:spPr>
           <a:xfrm rot="5400000">
-            <a:off x="14288127" y="1543577"/>
+            <a:off x="14288127" y="1065274"/>
             <a:ext cx="365725" cy="1249"/>
           </a:xfrm>
           <a:prstGeom prst="curvedConnector3">
@@ -8093,13 +8150,13 @@
         </p:spPr>
         <p:style>
           <a:lnRef idx="2">
-            <a:schemeClr val="accent1"/>
+            <a:schemeClr val="dk1"/>
           </a:lnRef>
           <a:fillRef idx="0">
-            <a:schemeClr val="accent1"/>
+            <a:schemeClr val="dk1"/>
           </a:fillRef>
           <a:effectRef idx="1">
-            <a:schemeClr val="accent1"/>
+            <a:schemeClr val="dk1"/>
           </a:effectRef>
           <a:fontRef idx="minor">
             <a:schemeClr val="tx1"/>
@@ -8124,7 +8181,7 @@
         </p:nvCxnSpPr>
         <p:spPr>
           <a:xfrm rot="16200000" flipH="1">
-            <a:off x="16481825" y="1525765"/>
+            <a:off x="16481825" y="1047462"/>
             <a:ext cx="341378" cy="12525"/>
           </a:xfrm>
           <a:prstGeom prst="curvedConnector3">
@@ -8138,13 +8195,13 @@
         </p:spPr>
         <p:style>
           <a:lnRef idx="2">
-            <a:schemeClr val="accent1"/>
+            <a:schemeClr val="dk1"/>
           </a:lnRef>
           <a:fillRef idx="0">
-            <a:schemeClr val="accent1"/>
+            <a:schemeClr val="dk1"/>
           </a:fillRef>
           <a:effectRef idx="1">
-            <a:schemeClr val="accent1"/>
+            <a:schemeClr val="dk1"/>
           </a:effectRef>
           <a:fontRef idx="minor">
             <a:schemeClr val="tx1"/>
@@ -8169,7 +8226,7 @@
         </p:nvCxnSpPr>
         <p:spPr>
           <a:xfrm rot="16200000" flipH="1">
-            <a:off x="14489566" y="2227692"/>
+            <a:off x="14489566" y="1749389"/>
             <a:ext cx="1100759" cy="1139162"/>
           </a:xfrm>
           <a:prstGeom prst="curvedConnector3">
@@ -8183,13 +8240,13 @@
         </p:spPr>
         <p:style>
           <a:lnRef idx="2">
-            <a:schemeClr val="accent1"/>
+            <a:schemeClr val="dk1"/>
           </a:lnRef>
           <a:fillRef idx="0">
-            <a:schemeClr val="accent1"/>
+            <a:schemeClr val="dk1"/>
           </a:fillRef>
           <a:effectRef idx="1">
-            <a:schemeClr val="accent1"/>
+            <a:schemeClr val="dk1"/>
           </a:effectRef>
           <a:fontRef idx="minor">
             <a:schemeClr val="tx1"/>
@@ -8214,7 +8271,7 @@
         </p:nvCxnSpPr>
         <p:spPr>
           <a:xfrm rot="5400000">
-            <a:off x="15571599" y="2260475"/>
+            <a:off x="15571599" y="1782172"/>
             <a:ext cx="1125106" cy="1049251"/>
           </a:xfrm>
           <a:prstGeom prst="curvedConnector3">
@@ -8228,13 +8285,13 @@
         </p:spPr>
         <p:style>
           <a:lnRef idx="2">
-            <a:schemeClr val="accent1"/>
+            <a:schemeClr val="dk1"/>
           </a:lnRef>
           <a:fillRef idx="0">
-            <a:schemeClr val="accent1"/>
+            <a:schemeClr val="dk1"/>
           </a:fillRef>
           <a:effectRef idx="1">
-            <a:schemeClr val="accent1"/>
+            <a:schemeClr val="dk1"/>
           </a:effectRef>
           <a:fontRef idx="minor">
             <a:schemeClr val="tx1"/>
@@ -8255,7 +8312,7 @@
         </p:nvSpPr>
         <p:spPr>
           <a:xfrm>
-            <a:off x="14000827" y="4267532"/>
+            <a:off x="14000827" y="3789229"/>
             <a:ext cx="1198308" cy="519830"/>
           </a:xfrm>
           <a:prstGeom prst="roundRect">
@@ -8311,7 +8368,7 @@
         </p:nvCxnSpPr>
         <p:spPr>
           <a:xfrm rot="5400000">
-            <a:off x="14904730" y="3562735"/>
+            <a:off x="14904730" y="3084432"/>
             <a:ext cx="400049" cy="1009545"/>
           </a:xfrm>
           <a:prstGeom prst="curvedConnector3">
@@ -8325,13 +8382,13 @@
         </p:spPr>
         <p:style>
           <a:lnRef idx="2">
-            <a:schemeClr val="accent1"/>
+            <a:schemeClr val="dk1"/>
           </a:lnRef>
           <a:fillRef idx="0">
-            <a:schemeClr val="accent1"/>
+            <a:schemeClr val="dk1"/>
           </a:fillRef>
           <a:effectRef idx="1">
-            <a:schemeClr val="accent1"/>
+            <a:schemeClr val="dk1"/>
           </a:effectRef>
           <a:fontRef idx="minor">
             <a:schemeClr val="tx1"/>
@@ -8352,7 +8409,7 @@
         </p:nvSpPr>
         <p:spPr>
           <a:xfrm>
-            <a:off x="16085309" y="4298993"/>
+            <a:off x="16085309" y="3820690"/>
             <a:ext cx="1198308" cy="519830"/>
           </a:xfrm>
           <a:prstGeom prst="roundRect">
@@ -8408,7 +8465,7 @@
         </p:nvCxnSpPr>
         <p:spPr>
           <a:xfrm rot="16200000" flipH="1">
-            <a:off x="15931239" y="3545769"/>
+            <a:off x="15931239" y="3067466"/>
             <a:ext cx="431510" cy="1074937"/>
           </a:xfrm>
           <a:prstGeom prst="curvedConnector3">
@@ -8422,13 +8479,13 @@
         </p:spPr>
         <p:style>
           <a:lnRef idx="2">
-            <a:schemeClr val="accent1"/>
+            <a:schemeClr val="dk1"/>
           </a:lnRef>
           <a:fillRef idx="0">
-            <a:schemeClr val="accent1"/>
+            <a:schemeClr val="dk1"/>
           </a:fillRef>
           <a:effectRef idx="1">
-            <a:schemeClr val="accent1"/>
+            <a:schemeClr val="dk1"/>
           </a:effectRef>
           <a:fontRef idx="minor">
             <a:schemeClr val="tx1"/>
@@ -8449,7 +8506,7 @@
         </p:nvSpPr>
         <p:spPr>
           <a:xfrm>
-            <a:off x="15095083" y="2291667"/>
+            <a:off x="15095083" y="1813364"/>
             <a:ext cx="1037572" cy="608551"/>
           </a:xfrm>
           <a:prstGeom prst="roundRect">
@@ -8507,7 +8564,7 @@
         </p:nvCxnSpPr>
         <p:spPr>
           <a:xfrm>
-            <a:off x="15140850" y="1986979"/>
+            <a:off x="15140850" y="1508676"/>
             <a:ext cx="473019" cy="304688"/>
           </a:xfrm>
           <a:prstGeom prst="curvedConnector2">
@@ -8519,13 +8576,13 @@
         </p:spPr>
         <p:style>
           <a:lnRef idx="2">
-            <a:schemeClr val="accent1"/>
+            <a:schemeClr val="dk1"/>
           </a:lnRef>
           <a:fillRef idx="0">
-            <a:schemeClr val="accent1"/>
+            <a:schemeClr val="dk1"/>
           </a:fillRef>
           <a:effectRef idx="1">
-            <a:schemeClr val="accent1"/>
+            <a:schemeClr val="dk1"/>
           </a:effectRef>
           <a:fontRef idx="minor">
             <a:schemeClr val="tx1"/>
@@ -8550,7 +8607,7 @@
         </p:nvCxnSpPr>
         <p:spPr>
           <a:xfrm>
-            <a:off x="16132655" y="2595943"/>
+            <a:off x="16132655" y="2117640"/>
             <a:ext cx="551808" cy="1703050"/>
           </a:xfrm>
           <a:prstGeom prst="curvedConnector2">
@@ -8562,13 +8619,13 @@
         </p:spPr>
         <p:style>
           <a:lnRef idx="2">
-            <a:schemeClr val="accent1"/>
+            <a:schemeClr val="dk1"/>
           </a:lnRef>
           <a:fillRef idx="0">
-            <a:schemeClr val="accent1"/>
+            <a:schemeClr val="dk1"/>
           </a:fillRef>
           <a:effectRef idx="1">
-            <a:schemeClr val="accent1"/>
+            <a:schemeClr val="dk1"/>
           </a:effectRef>
           <a:fontRef idx="minor">
             <a:schemeClr val="tx1"/>
@@ -8593,7 +8650,7 @@
         </p:nvCxnSpPr>
         <p:spPr>
           <a:xfrm rot="5400000">
-            <a:off x="15387981" y="3121764"/>
+            <a:off x="15387981" y="2643461"/>
             <a:ext cx="447435" cy="4343"/>
           </a:xfrm>
           <a:prstGeom prst="curvedConnector3">
@@ -8607,13 +8664,13 @@
         </p:spPr>
         <p:style>
           <a:lnRef idx="2">
-            <a:schemeClr val="accent1"/>
+            <a:schemeClr val="dk1"/>
           </a:lnRef>
           <a:fillRef idx="0">
-            <a:schemeClr val="accent1"/>
+            <a:schemeClr val="dk1"/>
           </a:fillRef>
           <a:effectRef idx="1">
-            <a:schemeClr val="accent1"/>
+            <a:schemeClr val="dk1"/>
           </a:effectRef>
           <a:fontRef idx="minor">
             <a:schemeClr val="tx1"/>
@@ -8634,7 +8691,7 @@
         </p:nvSpPr>
         <p:spPr>
           <a:xfrm>
-            <a:off x="15807776" y="5184099"/>
+            <a:off x="15807776" y="4705796"/>
             <a:ext cx="1037572" cy="519830"/>
           </a:xfrm>
           <a:prstGeom prst="roundRect">
@@ -8686,7 +8743,7 @@
         </p:nvSpPr>
         <p:spPr>
           <a:xfrm>
-            <a:off x="14376567" y="5171575"/>
+            <a:off x="14376567" y="4693272"/>
             <a:ext cx="1037572" cy="519830"/>
           </a:xfrm>
           <a:prstGeom prst="roundRect">
@@ -8742,7 +8799,7 @@
         </p:nvCxnSpPr>
         <p:spPr>
           <a:xfrm rot="5400000">
-            <a:off x="14600394" y="4162443"/>
+            <a:off x="14600394" y="3684140"/>
             <a:ext cx="1304092" cy="714173"/>
           </a:xfrm>
           <a:prstGeom prst="curvedConnector3">
@@ -8756,13 +8813,13 @@
         </p:spPr>
         <p:style>
           <a:lnRef idx="2">
-            <a:schemeClr val="accent1"/>
+            <a:schemeClr val="dk1"/>
           </a:lnRef>
           <a:fillRef idx="0">
-            <a:schemeClr val="accent1"/>
+            <a:schemeClr val="dk1"/>
           </a:fillRef>
           <a:effectRef idx="1">
-            <a:schemeClr val="accent1"/>
+            <a:schemeClr val="dk1"/>
           </a:effectRef>
           <a:fontRef idx="minor">
             <a:schemeClr val="tx1"/>
@@ -8787,7 +8844,7 @@
         </p:nvCxnSpPr>
         <p:spPr>
           <a:xfrm rot="5400000">
-            <a:off x="16322875" y="4822511"/>
+            <a:off x="16322875" y="4344208"/>
             <a:ext cx="365276" cy="357901"/>
           </a:xfrm>
           <a:prstGeom prst="curvedConnector3">
@@ -8801,13 +8858,13 @@
         </p:spPr>
         <p:style>
           <a:lnRef idx="2">
-            <a:schemeClr val="accent1"/>
+            <a:schemeClr val="dk1"/>
           </a:lnRef>
           <a:fillRef idx="0">
-            <a:schemeClr val="accent1"/>
+            <a:schemeClr val="dk1"/>
           </a:fillRef>
           <a:effectRef idx="1">
-            <a:schemeClr val="accent1"/>
+            <a:schemeClr val="dk1"/>
           </a:effectRef>
           <a:fontRef idx="minor">
             <a:schemeClr val="tx1"/>
@@ -8835,8 +8892,8 @@
             <a:avLst/>
           </a:prstGeom>
           <a:solidFill>
-            <a:schemeClr val="bg2">
-              <a:lumMod val="90000"/>
+            <a:schemeClr val="bg1">
+              <a:lumMod val="85000"/>
             </a:schemeClr>
           </a:solidFill>
         </p:spPr>
@@ -8874,15 +8931,15 @@
         </p:nvSpPr>
         <p:spPr>
           <a:xfrm>
-            <a:off x="7045428" y="5351083"/>
+            <a:off x="7031360" y="5379219"/>
             <a:ext cx="1323119" cy="400110"/>
           </a:xfrm>
           <a:prstGeom prst="rect">
             <a:avLst/>
           </a:prstGeom>
           <a:solidFill>
-            <a:schemeClr val="bg2">
-              <a:lumMod val="90000"/>
+            <a:schemeClr val="bg1">
+              <a:lumMod val="85000"/>
             </a:schemeClr>
           </a:solidFill>
         </p:spPr>
@@ -8927,8 +8984,8 @@
             <a:avLst/>
           </a:prstGeom>
           <a:solidFill>
-            <a:schemeClr val="bg2">
-              <a:lumMod val="90000"/>
+            <a:schemeClr val="bg1">
+              <a:lumMod val="85000"/>
             </a:schemeClr>
           </a:solidFill>
         </p:spPr>
@@ -8966,8 +9023,8 @@
             <a:avLst/>
           </a:prstGeom>
           <a:solidFill>
-            <a:schemeClr val="bg2">
-              <a:lumMod val="90000"/>
+            <a:schemeClr val="bg1">
+              <a:lumMod val="85000"/>
             </a:schemeClr>
           </a:solidFill>
         </p:spPr>
@@ -9005,15 +9062,15 @@
         </p:nvSpPr>
         <p:spPr>
           <a:xfrm>
-            <a:off x="15919345" y="6462746"/>
+            <a:off x="15722396" y="6027111"/>
             <a:ext cx="1324722" cy="400110"/>
           </a:xfrm>
           <a:prstGeom prst="rect">
             <a:avLst/>
           </a:prstGeom>
           <a:solidFill>
-            <a:schemeClr val="bg2">
-              <a:lumMod val="90000"/>
+            <a:schemeClr val="bg1">
+              <a:lumMod val="85000"/>
             </a:schemeClr>
           </a:solidFill>
         </p:spPr>
@@ -9051,7 +9108,7 @@
         </p:nvSpPr>
         <p:spPr>
           <a:xfrm>
-            <a:off x="2223836" y="39062"/>
+            <a:off x="1844007" y="39062"/>
             <a:ext cx="1037572" cy="519830"/>
           </a:xfrm>
           <a:prstGeom prst="roundRect">
@@ -9103,7 +9160,7 @@
         </p:nvSpPr>
         <p:spPr>
           <a:xfrm>
-            <a:off x="3264729" y="39886"/>
+            <a:off x="2884900" y="39886"/>
             <a:ext cx="1037572" cy="519830"/>
           </a:xfrm>
           <a:prstGeom prst="roundRect">
@@ -9157,7 +9214,7 @@
         </p:nvSpPr>
         <p:spPr>
           <a:xfrm>
-            <a:off x="4325809" y="36938"/>
+            <a:off x="3945980" y="36938"/>
             <a:ext cx="1180151" cy="519830"/>
           </a:xfrm>
           <a:prstGeom prst="roundRect">
@@ -9211,7 +9268,7 @@
         </p:nvSpPr>
         <p:spPr>
           <a:xfrm>
-            <a:off x="5504170" y="36938"/>
+            <a:off x="5124341" y="36938"/>
             <a:ext cx="1037572" cy="519830"/>
           </a:xfrm>
           <a:prstGeom prst="roundRect">
@@ -9265,7 +9322,7 @@
         </p:nvSpPr>
         <p:spPr>
           <a:xfrm>
-            <a:off x="6543988" y="37295"/>
+            <a:off x="6164159" y="37295"/>
             <a:ext cx="1401019" cy="519830"/>
           </a:xfrm>
           <a:prstGeom prst="roundRect">
@@ -9317,7 +9374,7 @@
         </p:nvSpPr>
         <p:spPr>
           <a:xfrm>
-            <a:off x="15090740" y="5980208"/>
+            <a:off x="15090740" y="5501905"/>
             <a:ext cx="1037572" cy="519830"/>
           </a:xfrm>
           <a:prstGeom prst="roundRect">
@@ -9371,7 +9428,7 @@
         </p:nvSpPr>
         <p:spPr>
           <a:xfrm rot="16200000">
-            <a:off x="15439006" y="3998289"/>
+            <a:off x="15439006" y="3519986"/>
             <a:ext cx="291590" cy="3577606"/>
           </a:xfrm>
           <a:prstGeom prst="leftBrace">
@@ -9380,13 +9437,13 @@
         </p:spPr>
         <p:style>
           <a:lnRef idx="2">
-            <a:schemeClr val="accent1"/>
+            <a:schemeClr val="dk1"/>
           </a:lnRef>
           <a:fillRef idx="0">
-            <a:schemeClr val="accent1"/>
+            <a:schemeClr val="dk1"/>
           </a:fillRef>
           <a:effectRef idx="1">
-            <a:schemeClr val="accent1"/>
+            <a:schemeClr val="dk1"/>
           </a:effectRef>
           <a:fontRef idx="minor">
             <a:schemeClr val="tx1"/>
@@ -9415,15 +9472,15 @@
         </p:nvSpPr>
         <p:spPr>
           <a:xfrm>
-            <a:off x="14834608" y="8245584"/>
+            <a:off x="15988157" y="9280894"/>
             <a:ext cx="1324722" cy="400110"/>
           </a:xfrm>
           <a:prstGeom prst="rect">
             <a:avLst/>
           </a:prstGeom>
           <a:solidFill>
-            <a:schemeClr val="bg2">
-              <a:lumMod val="90000"/>
+            <a:schemeClr val="bg1">
+              <a:lumMod val="85000"/>
             </a:schemeClr>
           </a:solidFill>
         </p:spPr>
@@ -9447,26 +9504,351 @@
           </a:p>
         </p:txBody>
       </p:sp>
+      <p:sp>
+        <p:nvSpPr>
+          <p:cNvPr id="55" name="Rounded Rectangle 54">
+            <a:extLst>
+              <a:ext uri="{FF2B5EF4-FFF2-40B4-BE49-F238E27FC236}">
+                <a16:creationId xmlns:a16="http://schemas.microsoft.com/office/drawing/2014/main" id="{A7D52A1F-A6EE-19F1-49CE-6E97CF8336EA}"/>
+              </a:ext>
+            </a:extLst>
+          </p:cNvPr>
+          <p:cNvSpPr/>
+          <p:nvPr/>
+        </p:nvSpPr>
+        <p:spPr>
+          <a:xfrm>
+            <a:off x="6513662" y="8766103"/>
+            <a:ext cx="1037572" cy="519830"/>
+          </a:xfrm>
+          <a:prstGeom prst="roundRect">
+            <a:avLst/>
+          </a:prstGeom>
+          <a:solidFill>
+            <a:schemeClr val="accent5">
+              <a:lumMod val="75000"/>
+            </a:schemeClr>
+          </a:solidFill>
+        </p:spPr>
+        <p:style>
+          <a:lnRef idx="2">
+            <a:schemeClr val="accent1">
+              <a:shade val="15000"/>
+            </a:schemeClr>
+          </a:lnRef>
+          <a:fillRef idx="1">
+            <a:schemeClr val="accent1"/>
+          </a:fillRef>
+          <a:effectRef idx="0">
+            <a:schemeClr val="accent1"/>
+          </a:effectRef>
+          <a:fontRef idx="minor">
+            <a:schemeClr val="lt1"/>
+          </a:fontRef>
+        </p:style>
+        <p:txBody>
+          <a:bodyPr rtlCol="0" anchor="ctr"/>
+          <a:lstStyle/>
+          <a:p>
+            <a:pPr algn="ctr"/>
+            <a:r>
+              <a:rPr lang="en-US" sz="1200" dirty="0"/>
+              <a:t>Ch2 Pipeline</a:t>
+            </a:r>
+          </a:p>
+        </p:txBody>
+      </p:sp>
+      <p:sp>
+        <p:nvSpPr>
+          <p:cNvPr id="9" name="Rounded Rectangle 8">
+            <a:extLst>
+              <a:ext uri="{FF2B5EF4-FFF2-40B4-BE49-F238E27FC236}">
+                <a16:creationId xmlns:a16="http://schemas.microsoft.com/office/drawing/2014/main" id="{64043CB4-B2AA-668E-3DD7-7A6ADB109051}"/>
+              </a:ext>
+            </a:extLst>
+          </p:cNvPr>
+          <p:cNvSpPr/>
+          <p:nvPr/>
+        </p:nvSpPr>
+        <p:spPr>
+          <a:xfrm>
+            <a:off x="14745278" y="8337641"/>
+            <a:ext cx="1381243" cy="604850"/>
+          </a:xfrm>
+          <a:prstGeom prst="roundRect">
+            <a:avLst/>
+          </a:prstGeom>
+          <a:solidFill>
+            <a:schemeClr val="tx1">
+              <a:lumMod val="95000"/>
+              <a:lumOff val="5000"/>
+            </a:schemeClr>
+          </a:solidFill>
+        </p:spPr>
+        <p:style>
+          <a:lnRef idx="2">
+            <a:schemeClr val="accent1">
+              <a:shade val="15000"/>
+            </a:schemeClr>
+          </a:lnRef>
+          <a:fillRef idx="1">
+            <a:schemeClr val="accent1"/>
+          </a:fillRef>
+          <a:effectRef idx="0">
+            <a:schemeClr val="accent1"/>
+          </a:effectRef>
+          <a:fontRef idx="minor">
+            <a:schemeClr val="lt1"/>
+          </a:fontRef>
+        </p:style>
+        <p:txBody>
+          <a:bodyPr rtlCol="0" anchor="ctr"/>
+          <a:lstStyle/>
+          <a:p>
+            <a:pPr algn="ctr"/>
+            <a:r>
+              <a:rPr lang="en-US" sz="1200" b="1" dirty="0"/>
+              <a:t>Product surface (App)</a:t>
+            </a:r>
+          </a:p>
+        </p:txBody>
+      </p:sp>
+      <p:sp>
+        <p:nvSpPr>
+          <p:cNvPr id="53" name="Rounded Rectangle 52">
+            <a:extLst>
+              <a:ext uri="{FF2B5EF4-FFF2-40B4-BE49-F238E27FC236}">
+                <a16:creationId xmlns:a16="http://schemas.microsoft.com/office/drawing/2014/main" id="{0147BC3A-6182-4D98-3491-13B7228AE982}"/>
+              </a:ext>
+            </a:extLst>
+          </p:cNvPr>
+          <p:cNvSpPr/>
+          <p:nvPr/>
+        </p:nvSpPr>
+        <p:spPr>
+          <a:xfrm>
+            <a:off x="6245030" y="4739008"/>
+            <a:ext cx="1037572" cy="519830"/>
+          </a:xfrm>
+          <a:prstGeom prst="roundRect">
+            <a:avLst/>
+          </a:prstGeom>
+          <a:solidFill>
+            <a:schemeClr val="accent5">
+              <a:lumMod val="75000"/>
+            </a:schemeClr>
+          </a:solidFill>
+        </p:spPr>
+        <p:style>
+          <a:lnRef idx="2">
+            <a:schemeClr val="accent1">
+              <a:shade val="15000"/>
+            </a:schemeClr>
+          </a:lnRef>
+          <a:fillRef idx="1">
+            <a:schemeClr val="accent1"/>
+          </a:fillRef>
+          <a:effectRef idx="0">
+            <a:schemeClr val="accent1"/>
+          </a:effectRef>
+          <a:fontRef idx="minor">
+            <a:schemeClr val="lt1"/>
+          </a:fontRef>
+        </p:style>
+        <p:txBody>
+          <a:bodyPr rtlCol="0" anchor="ctr"/>
+          <a:lstStyle/>
+          <a:p>
+            <a:pPr algn="ctr"/>
+            <a:r>
+              <a:rPr lang="en-US" sz="1200" dirty="0"/>
+              <a:t>Ch1 Pipeline</a:t>
+            </a:r>
+          </a:p>
+        </p:txBody>
+      </p:sp>
+      <p:sp>
+        <p:nvSpPr>
+          <p:cNvPr id="54" name="Rounded Rectangle 53">
+            <a:extLst>
+              <a:ext uri="{FF2B5EF4-FFF2-40B4-BE49-F238E27FC236}">
+                <a16:creationId xmlns:a16="http://schemas.microsoft.com/office/drawing/2014/main" id="{8DC41873-12CB-0309-4694-CF30D5953E55}"/>
+              </a:ext>
+            </a:extLst>
+          </p:cNvPr>
+          <p:cNvSpPr/>
+          <p:nvPr/>
+        </p:nvSpPr>
+        <p:spPr>
+          <a:xfrm>
+            <a:off x="13568820" y="7039269"/>
+            <a:ext cx="1037572" cy="519830"/>
+          </a:xfrm>
+          <a:prstGeom prst="roundRect">
+            <a:avLst/>
+          </a:prstGeom>
+          <a:solidFill>
+            <a:schemeClr val="accent5">
+              <a:lumMod val="75000"/>
+            </a:schemeClr>
+          </a:solidFill>
+        </p:spPr>
+        <p:style>
+          <a:lnRef idx="2">
+            <a:schemeClr val="accent1">
+              <a:shade val="15000"/>
+            </a:schemeClr>
+          </a:lnRef>
+          <a:fillRef idx="1">
+            <a:schemeClr val="accent1"/>
+          </a:fillRef>
+          <a:effectRef idx="0">
+            <a:schemeClr val="accent1"/>
+          </a:effectRef>
+          <a:fontRef idx="minor">
+            <a:schemeClr val="lt1"/>
+          </a:fontRef>
+        </p:style>
+        <p:txBody>
+          <a:bodyPr rtlCol="0" anchor="ctr"/>
+          <a:lstStyle/>
+          <a:p>
+            <a:pPr algn="ctr"/>
+            <a:r>
+              <a:rPr lang="en-US" sz="1200" dirty="0"/>
+              <a:t>Ch1 Pipeline</a:t>
+            </a:r>
+          </a:p>
+        </p:txBody>
+      </p:sp>
+      <p:sp>
+        <p:nvSpPr>
+          <p:cNvPr id="57" name="Rounded Rectangle 56">
+            <a:extLst>
+              <a:ext uri="{FF2B5EF4-FFF2-40B4-BE49-F238E27FC236}">
+                <a16:creationId xmlns:a16="http://schemas.microsoft.com/office/drawing/2014/main" id="{1C9ECCC1-B82B-5BF7-D846-73C8CD1D95E4}"/>
+              </a:ext>
+            </a:extLst>
+          </p:cNvPr>
+          <p:cNvSpPr/>
+          <p:nvPr/>
+        </p:nvSpPr>
+        <p:spPr>
+          <a:xfrm>
+            <a:off x="16279039" y="7047568"/>
+            <a:ext cx="1037572" cy="528635"/>
+          </a:xfrm>
+          <a:prstGeom prst="roundRect">
+            <a:avLst/>
+          </a:prstGeom>
+          <a:solidFill>
+            <a:schemeClr val="accent5">
+              <a:lumMod val="75000"/>
+            </a:schemeClr>
+          </a:solidFill>
+        </p:spPr>
+        <p:style>
+          <a:lnRef idx="2">
+            <a:schemeClr val="accent1">
+              <a:shade val="15000"/>
+            </a:schemeClr>
+          </a:lnRef>
+          <a:fillRef idx="1">
+            <a:schemeClr val="accent1"/>
+          </a:fillRef>
+          <a:effectRef idx="0">
+            <a:schemeClr val="accent1"/>
+          </a:effectRef>
+          <a:fontRef idx="minor">
+            <a:schemeClr val="lt1"/>
+          </a:fontRef>
+        </p:style>
+        <p:txBody>
+          <a:bodyPr rtlCol="0" anchor="ctr"/>
+          <a:lstStyle/>
+          <a:p>
+            <a:pPr algn="ctr"/>
+            <a:r>
+              <a:rPr lang="en-US" sz="1200" dirty="0"/>
+              <a:t>Ch4 Pipeline</a:t>
+            </a:r>
+          </a:p>
+        </p:txBody>
+      </p:sp>
+      <p:sp>
+        <p:nvSpPr>
+          <p:cNvPr id="58" name="Rounded Rectangle 57">
+            <a:extLst>
+              <a:ext uri="{FF2B5EF4-FFF2-40B4-BE49-F238E27FC236}">
+                <a16:creationId xmlns:a16="http://schemas.microsoft.com/office/drawing/2014/main" id="{199E6B1D-8C9F-39AA-5D5A-6653F973E8F9}"/>
+              </a:ext>
+            </a:extLst>
+          </p:cNvPr>
+          <p:cNvSpPr/>
+          <p:nvPr/>
+        </p:nvSpPr>
+        <p:spPr>
+          <a:xfrm>
+            <a:off x="14917114" y="7051971"/>
+            <a:ext cx="1037572" cy="519829"/>
+          </a:xfrm>
+          <a:prstGeom prst="roundRect">
+            <a:avLst/>
+          </a:prstGeom>
+          <a:solidFill>
+            <a:schemeClr val="accent5">
+              <a:lumMod val="75000"/>
+            </a:schemeClr>
+          </a:solidFill>
+        </p:spPr>
+        <p:style>
+          <a:lnRef idx="2">
+            <a:schemeClr val="accent1">
+              <a:shade val="15000"/>
+            </a:schemeClr>
+          </a:lnRef>
+          <a:fillRef idx="1">
+            <a:schemeClr val="accent1"/>
+          </a:fillRef>
+          <a:effectRef idx="0">
+            <a:schemeClr val="accent1"/>
+          </a:effectRef>
+          <a:fontRef idx="minor">
+            <a:schemeClr val="lt1"/>
+          </a:fontRef>
+        </p:style>
+        <p:txBody>
+          <a:bodyPr rtlCol="0" anchor="ctr"/>
+          <a:lstStyle/>
+          <a:p>
+            <a:pPr algn="ctr"/>
+            <a:r>
+              <a:rPr lang="en-US" sz="1200" dirty="0"/>
+              <a:t>Ch2 Pipeline</a:t>
+            </a:r>
+          </a:p>
+        </p:txBody>
+      </p:sp>
       <p:cxnSp>
         <p:nvCxnSpPr>
-          <p:cNvPr id="6" name="Curved Connector 5">
-            <a:extLst>
-              <a:ext uri="{FF2B5EF4-FFF2-40B4-BE49-F238E27FC236}">
-                <a16:creationId xmlns:a16="http://schemas.microsoft.com/office/drawing/2014/main" id="{5973B622-0998-046C-77E0-3303001AAEE3}"/>
+          <p:cNvPr id="60" name="Curved Connector 59">
+            <a:extLst>
+              <a:ext uri="{FF2B5EF4-FFF2-40B4-BE49-F238E27FC236}">
+                <a16:creationId xmlns:a16="http://schemas.microsoft.com/office/drawing/2014/main" id="{3BD41A04-8843-A9C0-C1FC-170F4D5EA6E5}"/>
               </a:ext>
             </a:extLst>
           </p:cNvPr>
           <p:cNvCxnSpPr>
             <a:cxnSpLocks/>
-            <a:stCxn id="29" idx="3"/>
-            <a:endCxn id="5" idx="1"/>
+            <a:stCxn id="54" idx="2"/>
+            <a:endCxn id="9" idx="0"/>
           </p:cNvCxnSpPr>
           <p:nvPr/>
         </p:nvCxnSpPr>
         <p:spPr>
-          <a:xfrm>
-            <a:off x="6066021" y="5157015"/>
-            <a:ext cx="8768587" cy="3288624"/>
+          <a:xfrm rot="16200000" flipH="1">
+            <a:off x="14372482" y="7274223"/>
+            <a:ext cx="778542" cy="1348294"/>
           </a:xfrm>
           <a:prstGeom prst="curvedConnector3">
             <a:avLst>
@@ -9479,13 +9861,13 @@
         </p:spPr>
         <p:style>
           <a:lnRef idx="2">
-            <a:schemeClr val="accent1"/>
+            <a:schemeClr val="dk1"/>
           </a:lnRef>
           <a:fillRef idx="0">
-            <a:schemeClr val="accent1"/>
+            <a:schemeClr val="dk1"/>
           </a:fillRef>
           <a:effectRef idx="1">
-            <a:schemeClr val="accent1"/>
+            <a:schemeClr val="dk1"/>
           </a:effectRef>
           <a:fontRef idx="minor">
             <a:schemeClr val="tx1"/>
@@ -9494,24 +9876,24 @@
       </p:cxnSp>
       <p:cxnSp>
         <p:nvCxnSpPr>
-          <p:cNvPr id="10" name="Curved Connector 9">
-            <a:extLst>
-              <a:ext uri="{FF2B5EF4-FFF2-40B4-BE49-F238E27FC236}">
-                <a16:creationId xmlns:a16="http://schemas.microsoft.com/office/drawing/2014/main" id="{986D04EA-98A9-6A49-23BD-D5097414E727}"/>
+          <p:cNvPr id="63" name="Curved Connector 62">
+            <a:extLst>
+              <a:ext uri="{FF2B5EF4-FFF2-40B4-BE49-F238E27FC236}">
+                <a16:creationId xmlns:a16="http://schemas.microsoft.com/office/drawing/2014/main" id="{58365BFD-5B89-0730-0726-C818D6E94671}"/>
               </a:ext>
             </a:extLst>
           </p:cNvPr>
           <p:cNvCxnSpPr>
             <a:cxnSpLocks/>
-            <a:stCxn id="4" idx="2"/>
-            <a:endCxn id="5" idx="0"/>
+            <a:stCxn id="58" idx="2"/>
+            <a:endCxn id="9" idx="0"/>
           </p:cNvCxnSpPr>
           <p:nvPr/>
         </p:nvCxnSpPr>
         <p:spPr>
           <a:xfrm rot="5400000">
-            <a:off x="14680475" y="7316533"/>
-            <a:ext cx="1745546" cy="112557"/>
+            <a:off x="15052980" y="7954720"/>
+            <a:ext cx="765841" cy="12700"/>
           </a:xfrm>
           <a:prstGeom prst="curvedConnector3">
             <a:avLst>
@@ -9524,13 +9906,13 @@
         </p:spPr>
         <p:style>
           <a:lnRef idx="2">
-            <a:schemeClr val="accent1"/>
+            <a:schemeClr val="dk1"/>
           </a:lnRef>
           <a:fillRef idx="0">
-            <a:schemeClr val="accent1"/>
+            <a:schemeClr val="dk1"/>
           </a:fillRef>
           <a:effectRef idx="1">
-            <a:schemeClr val="accent1"/>
+            <a:schemeClr val="dk1"/>
           </a:effectRef>
           <a:fontRef idx="minor">
             <a:schemeClr val="tx1"/>
@@ -9539,28 +9921,28 @@
       </p:cxnSp>
       <p:cxnSp>
         <p:nvCxnSpPr>
-          <p:cNvPr id="50" name="Curved Connector 49">
-            <a:extLst>
-              <a:ext uri="{FF2B5EF4-FFF2-40B4-BE49-F238E27FC236}">
-                <a16:creationId xmlns:a16="http://schemas.microsoft.com/office/drawing/2014/main" id="{915ECB82-53E8-3D8E-5DB5-BA4805EAEDA7}"/>
+          <p:cNvPr id="451" name="Curved Connector 450">
+            <a:extLst>
+              <a:ext uri="{FF2B5EF4-FFF2-40B4-BE49-F238E27FC236}">
+                <a16:creationId xmlns:a16="http://schemas.microsoft.com/office/drawing/2014/main" id="{03111E0C-ADDE-2D76-595D-849D5939EE68}"/>
               </a:ext>
             </a:extLst>
           </p:cNvPr>
           <p:cNvCxnSpPr>
             <a:cxnSpLocks/>
-            <a:stCxn id="36" idx="2"/>
-            <a:endCxn id="5" idx="2"/>
+            <a:stCxn id="57" idx="2"/>
+            <a:endCxn id="9" idx="0"/>
           </p:cNvCxnSpPr>
           <p:nvPr/>
         </p:nvCxnSpPr>
         <p:spPr>
-          <a:xfrm rot="16200000" flipH="1">
-            <a:off x="11693018" y="4841743"/>
-            <a:ext cx="57908" cy="7549993"/>
+          <a:xfrm rot="5400000">
+            <a:off x="15736144" y="7275960"/>
+            <a:ext cx="761438" cy="1361925"/>
           </a:xfrm>
           <a:prstGeom prst="curvedConnector3">
             <a:avLst>
-              <a:gd name="adj1" fmla="val 494764"/>
+              <a:gd name="adj1" fmla="val 50000"/>
             </a:avLst>
           </a:prstGeom>
           <a:ln>
@@ -9569,73 +9951,19 @@
         </p:spPr>
         <p:style>
           <a:lnRef idx="2">
-            <a:schemeClr val="accent1"/>
+            <a:schemeClr val="dk1"/>
           </a:lnRef>
           <a:fillRef idx="0">
-            <a:schemeClr val="accent1"/>
+            <a:schemeClr val="dk1"/>
           </a:fillRef>
           <a:effectRef idx="1">
-            <a:schemeClr val="accent1"/>
+            <a:schemeClr val="dk1"/>
           </a:effectRef>
           <a:fontRef idx="minor">
             <a:schemeClr val="tx1"/>
           </a:fontRef>
         </p:style>
       </p:cxnSp>
-      <p:sp>
-        <p:nvSpPr>
-          <p:cNvPr id="55" name="Rounded Rectangle 54">
-            <a:extLst>
-              <a:ext uri="{FF2B5EF4-FFF2-40B4-BE49-F238E27FC236}">
-                <a16:creationId xmlns:a16="http://schemas.microsoft.com/office/drawing/2014/main" id="{A7D52A1F-A6EE-19F1-49CE-6E97CF8336EA}"/>
-              </a:ext>
-            </a:extLst>
-          </p:cNvPr>
-          <p:cNvSpPr/>
-          <p:nvPr/>
-        </p:nvSpPr>
-        <p:spPr>
-          <a:xfrm>
-            <a:off x="6513662" y="8766103"/>
-            <a:ext cx="1037572" cy="519830"/>
-          </a:xfrm>
-          <a:prstGeom prst="roundRect">
-            <a:avLst/>
-          </a:prstGeom>
-          <a:solidFill>
-            <a:schemeClr val="accent5">
-              <a:lumMod val="75000"/>
-            </a:schemeClr>
-          </a:solidFill>
-        </p:spPr>
-        <p:style>
-          <a:lnRef idx="2">
-            <a:schemeClr val="accent1">
-              <a:shade val="15000"/>
-            </a:schemeClr>
-          </a:lnRef>
-          <a:fillRef idx="1">
-            <a:schemeClr val="accent1"/>
-          </a:fillRef>
-          <a:effectRef idx="0">
-            <a:schemeClr val="accent1"/>
-          </a:effectRef>
-          <a:fontRef idx="minor">
-            <a:schemeClr val="lt1"/>
-          </a:fontRef>
-        </p:style>
-        <p:txBody>
-          <a:bodyPr rtlCol="0" anchor="ctr"/>
-          <a:lstStyle/>
-          <a:p>
-            <a:pPr algn="ctr"/>
-            <a:r>
-              <a:rPr lang="en-US" sz="1200" dirty="0"/>
-              <a:t>Ch2 Pipeline</a:t>
-            </a:r>
-          </a:p>
-        </p:txBody>
-      </p:sp>
     </p:spTree>
     <p:extLst>
       <p:ext uri="{BB962C8B-B14F-4D97-AF65-F5344CB8AC3E}">

</xml_diff>

<commit_message>
Updated visual_overview.png in Media
</commit_message>
<xml_diff>
--- a/docs/narrative/visual_overview.pptx
+++ b/docs/narrative/visual_overview.pptx
@@ -244,7 +244,7 @@
           <a:p>
             <a:fld id="{EE9F2C0D-35DE-C142-87D7-63D989E280B6}" type="datetimeFigureOut">
               <a:rPr lang="en-US" smtClean="0"/>
-              <a:t>12/31/25</a:t>
+              <a:t>1/2/26</a:t>
             </a:fld>
             <a:endParaRPr lang="en-US"/>
           </a:p>
@@ -414,7 +414,7 @@
           <a:p>
             <a:fld id="{EE9F2C0D-35DE-C142-87D7-63D989E280B6}" type="datetimeFigureOut">
               <a:rPr lang="en-US" smtClean="0"/>
-              <a:t>12/31/25</a:t>
+              <a:t>1/2/26</a:t>
             </a:fld>
             <a:endParaRPr lang="en-US"/>
           </a:p>
@@ -594,7 +594,7 @@
           <a:p>
             <a:fld id="{EE9F2C0D-35DE-C142-87D7-63D989E280B6}" type="datetimeFigureOut">
               <a:rPr lang="en-US" smtClean="0"/>
-              <a:t>12/31/25</a:t>
+              <a:t>1/2/26</a:t>
             </a:fld>
             <a:endParaRPr lang="en-US"/>
           </a:p>
@@ -764,7 +764,7 @@
           <a:p>
             <a:fld id="{EE9F2C0D-35DE-C142-87D7-63D989E280B6}" type="datetimeFigureOut">
               <a:rPr lang="en-US" smtClean="0"/>
-              <a:t>12/31/25</a:t>
+              <a:t>1/2/26</a:t>
             </a:fld>
             <a:endParaRPr lang="en-US"/>
           </a:p>
@@ -1010,7 +1010,7 @@
           <a:p>
             <a:fld id="{EE9F2C0D-35DE-C142-87D7-63D989E280B6}" type="datetimeFigureOut">
               <a:rPr lang="en-US" smtClean="0"/>
-              <a:t>12/31/25</a:t>
+              <a:t>1/2/26</a:t>
             </a:fld>
             <a:endParaRPr lang="en-US"/>
           </a:p>
@@ -1242,7 +1242,7 @@
           <a:p>
             <a:fld id="{EE9F2C0D-35DE-C142-87D7-63D989E280B6}" type="datetimeFigureOut">
               <a:rPr lang="en-US" smtClean="0"/>
-              <a:t>12/31/25</a:t>
+              <a:t>1/2/26</a:t>
             </a:fld>
             <a:endParaRPr lang="en-US"/>
           </a:p>
@@ -1609,7 +1609,7 @@
           <a:p>
             <a:fld id="{EE9F2C0D-35DE-C142-87D7-63D989E280B6}" type="datetimeFigureOut">
               <a:rPr lang="en-US" smtClean="0"/>
-              <a:t>12/31/25</a:t>
+              <a:t>1/2/26</a:t>
             </a:fld>
             <a:endParaRPr lang="en-US"/>
           </a:p>
@@ -1727,7 +1727,7 @@
           <a:p>
             <a:fld id="{EE9F2C0D-35DE-C142-87D7-63D989E280B6}" type="datetimeFigureOut">
               <a:rPr lang="en-US" smtClean="0"/>
-              <a:t>12/31/25</a:t>
+              <a:t>1/2/26</a:t>
             </a:fld>
             <a:endParaRPr lang="en-US"/>
           </a:p>
@@ -1822,7 +1822,7 @@
           <a:p>
             <a:fld id="{EE9F2C0D-35DE-C142-87D7-63D989E280B6}" type="datetimeFigureOut">
               <a:rPr lang="en-US" smtClean="0"/>
-              <a:t>12/31/25</a:t>
+              <a:t>1/2/26</a:t>
             </a:fld>
             <a:endParaRPr lang="en-US"/>
           </a:p>
@@ -2099,7 +2099,7 @@
           <a:p>
             <a:fld id="{EE9F2C0D-35DE-C142-87D7-63D989E280B6}" type="datetimeFigureOut">
               <a:rPr lang="en-US" smtClean="0"/>
-              <a:t>12/31/25</a:t>
+              <a:t>1/2/26</a:t>
             </a:fld>
             <a:endParaRPr lang="en-US"/>
           </a:p>
@@ -2356,7 +2356,7 @@
           <a:p>
             <a:fld id="{EE9F2C0D-35DE-C142-87D7-63D989E280B6}" type="datetimeFigureOut">
               <a:rPr lang="en-US" smtClean="0"/>
-              <a:t>12/31/25</a:t>
+              <a:t>1/2/26</a:t>
             </a:fld>
             <a:endParaRPr lang="en-US"/>
           </a:p>
@@ -2569,7 +2569,7 @@
           <a:p>
             <a:fld id="{EE9F2C0D-35DE-C142-87D7-63D989E280B6}" type="datetimeFigureOut">
               <a:rPr lang="en-US" smtClean="0"/>
-              <a:t>12/31/25</a:t>
+              <a:t>1/2/26</a:t>
             </a:fld>
             <a:endParaRPr lang="en-US"/>
           </a:p>
@@ -3881,10 +3881,9 @@
           <a:p>
             <a:pPr algn="ctr"/>
             <a:r>
-              <a:rPr lang="en-US" sz="1200" dirty="0" err="1"/>
+              <a:rPr lang="en-US" sz="1200" dirty="0"/>
               <a:t>XGBRegresssor</a:t>
             </a:r>
-            <a:endParaRPr lang="en-US" sz="1200" dirty="0"/>
           </a:p>
         </p:txBody>
       </p:sp>
@@ -3943,10 +3942,9 @@
           <a:p>
             <a:pPr algn="ctr"/>
             <a:r>
-              <a:rPr lang="en-US" sz="1200" dirty="0" err="1"/>
+              <a:rPr lang="en-US" sz="1200" dirty="0"/>
               <a:t>LGBMClassifier</a:t>
             </a:r>
-            <a:endParaRPr lang="en-US" sz="1200" dirty="0"/>
           </a:p>
         </p:txBody>
       </p:sp>
@@ -4262,12 +4260,8 @@
           <a:p>
             <a:pPr algn="ctr"/>
             <a:r>
-              <a:rPr lang="en-US" sz="1200" dirty="0" err="1"/>
-              <a:t>Networkx</a:t>
-            </a:r>
-            <a:r>
               <a:rPr lang="en-US" sz="1200" dirty="0"/>
-              <a:t> bipartite</a:t>
+              <a:t>Networkx bipartite</a:t>
             </a:r>
           </a:p>
         </p:txBody>
@@ -4388,10 +4382,9 @@
           <a:p>
             <a:pPr algn="ctr"/>
             <a:r>
-              <a:rPr lang="en-US" sz="1200" dirty="0" err="1"/>
+              <a:rPr lang="en-US" sz="1200" dirty="0"/>
               <a:t>Kmeans</a:t>
             </a:r>
-            <a:endParaRPr lang="en-US" sz="1200" dirty="0"/>
           </a:p>
         </p:txBody>
       </p:sp>
@@ -5515,10 +5508,9 @@
           <a:p>
             <a:pPr algn="ctr"/>
             <a:r>
-              <a:rPr lang="en-US" sz="1200" dirty="0" err="1"/>
+              <a:rPr lang="en-US" sz="1200" dirty="0"/>
               <a:t>KMeans</a:t>
             </a:r>
-            <a:endParaRPr lang="en-US" sz="1200" dirty="0"/>
           </a:p>
         </p:txBody>
       </p:sp>
@@ -10322,10 +10314,9 @@
           <a:p>
             <a:pPr algn="ctr"/>
             <a:r>
-              <a:rPr lang="en-US" sz="1200" dirty="0" err="1"/>
+              <a:rPr lang="en-US" sz="1200" dirty="0"/>
               <a:t>XGBRegresssor</a:t>
             </a:r>
-            <a:endParaRPr lang="en-US" sz="1200" dirty="0"/>
           </a:p>
         </p:txBody>
       </p:sp>
@@ -10384,10 +10375,9 @@
           <a:p>
             <a:pPr algn="ctr"/>
             <a:r>
-              <a:rPr lang="en-US" sz="1200" dirty="0" err="1"/>
+              <a:rPr lang="en-US" sz="1200" dirty="0"/>
               <a:t>LGBMClassifier</a:t>
             </a:r>
-            <a:endParaRPr lang="en-US" sz="1200" dirty="0"/>
           </a:p>
         </p:txBody>
       </p:sp>
@@ -10554,12 +10544,8 @@
           <a:p>
             <a:pPr algn="ctr"/>
             <a:r>
-              <a:rPr lang="en-US" sz="1200" dirty="0" err="1"/>
-              <a:t>Networkx</a:t>
-            </a:r>
-            <a:r>
               <a:rPr lang="en-US" sz="1200" dirty="0"/>
-              <a:t> bipartite</a:t>
+              <a:t>Networkx bipartite</a:t>
             </a:r>
           </a:p>
         </p:txBody>
@@ -10680,10 +10666,9 @@
           <a:p>
             <a:pPr algn="ctr"/>
             <a:r>
-              <a:rPr lang="en-US" sz="1200" dirty="0" err="1"/>
+              <a:rPr lang="en-US" sz="1200" dirty="0"/>
               <a:t>Kmeans</a:t>
             </a:r>
-            <a:endParaRPr lang="en-US" sz="1200" dirty="0"/>
           </a:p>
         </p:txBody>
       </p:sp>

</xml_diff>